<commit_message>
Add underwater ambience and nonmetal saltwater material proposal
</commit_message>
<xml_diff>
--- a/DBA_Product_Overview_RevF.pptx
+++ b/DBA_Product_Overview_RevF.pptx
@@ -2,24 +2,24 @@
 <file path=ppt/presentation.xml><?xml version="1.0" encoding="utf-8"?>
 <p:presentation xmlns:p="http://schemas.openxmlformats.org/presentationml/2006/main">
   <p:sldMasterIdLst>
-    <p:sldMasterId xmlns:r="http://schemas.openxmlformats.org/officeDocument/2006/relationships" id="2147483648" r:id="Rd4ac93954e754eb8"/>
+    <p:sldMasterId xmlns:r="http://schemas.openxmlformats.org/officeDocument/2006/relationships" id="2147483648" r:id="R64b45ac822f54208"/>
   </p:sldMasterIdLst>
   <p:notesMasterIdLst>
-    <p:notesMasterId xmlns:r="http://schemas.openxmlformats.org/officeDocument/2006/relationships" r:id="R0e5519b60d2e4e1a"/>
+    <p:notesMasterId xmlns:r="http://schemas.openxmlformats.org/officeDocument/2006/relationships" r:id="Rd10e23bff1c14b1d"/>
   </p:notesMasterIdLst>
   <p:sldIdLst>
-    <p:sldId xmlns:r="http://schemas.openxmlformats.org/officeDocument/2006/relationships" id="256" r:id="R8d965e5346b04eff"/>
-    <p:sldId xmlns:r="http://schemas.openxmlformats.org/officeDocument/2006/relationships" id="257" r:id="R47b3ad4871104ba8"/>
-    <p:sldId xmlns:r="http://schemas.openxmlformats.org/officeDocument/2006/relationships" id="258" r:id="Rf4f6c07aadca4363"/>
-    <p:sldId xmlns:r="http://schemas.openxmlformats.org/officeDocument/2006/relationships" id="259" r:id="R9cf07be4f89f434f"/>
-    <p:sldId xmlns:r="http://schemas.openxmlformats.org/officeDocument/2006/relationships" id="260" r:id="Re2d673e09bda4493"/>
-    <p:sldId xmlns:r="http://schemas.openxmlformats.org/officeDocument/2006/relationships" id="261" r:id="Re279b86a465d4863"/>
-    <p:sldId xmlns:r="http://schemas.openxmlformats.org/officeDocument/2006/relationships" id="262" r:id="Rc8925162447b44e0"/>
-    <p:sldId xmlns:r="http://schemas.openxmlformats.org/officeDocument/2006/relationships" id="263" r:id="R0a6db8d598964fed"/>
-    <p:sldId xmlns:r="http://schemas.openxmlformats.org/officeDocument/2006/relationships" id="264" r:id="Rb6db3d6b60ba40f7"/>
-    <p:sldId xmlns:r="http://schemas.openxmlformats.org/officeDocument/2006/relationships" id="265" r:id="R86f3ab7a75c94223"/>
-    <p:sldId xmlns:r="http://schemas.openxmlformats.org/officeDocument/2006/relationships" id="266" r:id="Rf1f260d2a8d84aa7"/>
-    <p:sldId xmlns:r="http://schemas.openxmlformats.org/officeDocument/2006/relationships" id="267" r:id="R7b4a069485604526"/>
+    <p:sldId xmlns:r="http://schemas.openxmlformats.org/officeDocument/2006/relationships" id="256" r:id="R4ce1cef5745b436a"/>
+    <p:sldId xmlns:r="http://schemas.openxmlformats.org/officeDocument/2006/relationships" id="257" r:id="R729abd53893149fe"/>
+    <p:sldId xmlns:r="http://schemas.openxmlformats.org/officeDocument/2006/relationships" id="258" r:id="Rae94467d73ef433c"/>
+    <p:sldId xmlns:r="http://schemas.openxmlformats.org/officeDocument/2006/relationships" id="259" r:id="R89c9360dd0354b73"/>
+    <p:sldId xmlns:r="http://schemas.openxmlformats.org/officeDocument/2006/relationships" id="260" r:id="R4f8cfd22c61945d1"/>
+    <p:sldId xmlns:r="http://schemas.openxmlformats.org/officeDocument/2006/relationships" id="261" r:id="R89c4f5acdafe4c52"/>
+    <p:sldId xmlns:r="http://schemas.openxmlformats.org/officeDocument/2006/relationships" id="262" r:id="R8d57a22d374a4064"/>
+    <p:sldId xmlns:r="http://schemas.openxmlformats.org/officeDocument/2006/relationships" id="263" r:id="Rd4752a7352f64919"/>
+    <p:sldId xmlns:r="http://schemas.openxmlformats.org/officeDocument/2006/relationships" id="264" r:id="Rcb07b83bf89844a6"/>
+    <p:sldId xmlns:r="http://schemas.openxmlformats.org/officeDocument/2006/relationships" id="265" r:id="Rfec9f3e198784536"/>
+    <p:sldId xmlns:r="http://schemas.openxmlformats.org/officeDocument/2006/relationships" id="266" r:id="Rba966e2cbc8844d3"/>
+    <p:sldId xmlns:r="http://schemas.openxmlformats.org/officeDocument/2006/relationships" id="267" r:id="Rd49145b647ce4649"/>
   </p:sldIdLst>
   <p:sldSz cx="12192000" cy="6858000"/>
   <p:notesSz cx="6858000" cy="9144000"/>
@@ -533,7 +533,7 @@
           <a:lstStyle xmlns:a="http://schemas.openxmlformats.org/drawingml/2006/main"/>
           <a:p xmlns:a="http://schemas.openxmlformats.org/drawingml/2006/main">
             <a:r>
-              <a:t>The Rev F housing is 54 × 38 × 19.5 mm, excluding 2.2 mm button protrusion. The display body is 26 × 26 × 3 mm with 28 × 28 × 1.2 mm window and 24 × 24 mm active area. Eighteen modeled envelopes include pressure/heading sensors and adjustment hardware. Coil beneath the button side receives inductive charging through the sealed cap. Component availability, wiring, pressure coupling, supports, tolerances and sealing are unestablished.</a:t>
+              <a:t>The Rev F housing is 54 × 38 × 19.5 mm, excluding 2.2 mm button protrusion. The display body is 26 × 26 × 3 mm with 28 × 28 × 1.2 mm window and 24 × 24 mm active area. Eighteen modeled envelopes include pressure/heading sensors and adjustment hardware. Coil beneath the button side receives inductive charging through the sealed cap. The exterior housing and window are proposed nonmetal materials, with electronics isolated from seawater and no exposed charging contacts. Material grades, wiring, pressure coupling, supports, tolerances and sealing are unestablished.</a:t>
             </a:r>
           </a:p>
           <a:p xmlns:a="http://schemas.openxmlformats.org/drawingml/2006/main">
@@ -1253,7 +1253,7 @@
           <a:lstStyle xmlns:a="http://schemas.openxmlformats.org/drawingml/2006/main"/>
           <a:p xmlns:a="http://schemas.openxmlformats.org/drawingml/2006/main">
             <a:r>
-              <a:t>A split silicone strap wraps around the wrist or suit cuff. Its overlapping tail, adjustment holes, buckle and keeper provide mechanical adjustment; silicone compliance provides comfort. The sealed module remains removable when the strap needs replacing. Compact, Regular and Cuff are three modeled layouts, with nominal internal reference diameters of 50, 62 and 78 mm. Their circular reference circumferences are about 157, 195 and 245 mm. These dimensions describe CAD layouts; they are not established wrist-size ranges. Hole engagement, buckle retention, adjustment travel, silicone hardness and compression over a suit still require definition. Elasticity alone is no longer the fit mechanism. No clamping force or safe stretch has been established.</a:t>
+              <a:t>A split silicone strap wraps around the wrist or suit cuff. Its overlapping tail adjusts through a proposed acetal buckle, with a silicone keeper securing the loose end. The sealed module remains removable when the strap needs replacing. Compact, Regular and Cuff are three modeled layouts, with nominal internal reference diameters of 50, 62 and 78 mm. Their circular reference circumferences are about 157, 195 and 245 mm. These dimensions describe CAD layouts; they are not established wrist-size ranges. Corrosion resistance is a design requirement. The proposed exterior combines silicone, an acetal buckle with nonmetal retention, and a polymer housing and window. No exposed steel pin or charging contacts are specified. Material grades, seal durability, buckle strength and the usable fit range remain unvalidated.</a:t>
             </a:r>
           </a:p>
           <a:p xmlns:a="http://schemas.openxmlformats.org/drawingml/2006/main">
@@ -1333,7 +1333,7 @@
           <a:lstStyle xmlns:a="http://schemas.openxmlformats.org/drawingml/2006/main"/>
           <a:p xmlns:a="http://schemas.openxmlformats.org/drawingml/2006/main">
             <a:r>
-              <a:t>Compact, Regular and Cuff are three modeled layouts, with nominal internal reference diameters of 50, 62 and 78 mm. Their circular reference circumferences are about 157, 195 and 245 mm. These dimensions describe CAD layouts; they are not established wrist-size ranges. The main strap is 24 mm wide and 4 mm thick; the overlap tail is 22 mm wide and 2.4 mm thick with ten 3.5 mm holes. Buckle and keeper are geometric envelopes; pin engagement, latch, mounting and retention are not detailed. Silicone elasticity supplements mechanical adjustment. Supported wearer ranges are not established.</a:t>
+              <a:t>Compact, Regular and Cuff are three modeled layouts, with nominal internal reference diameters of 50, 62 and 78 mm. Their circular reference circumferences are about 157, 195 and 245 mm. These dimensions describe CAD layouts; they are not established wrist-size ranges. The main strap is 24 mm wide and 4 mm thick; the overlap tail is 22 mm wide and 2.4 mm thick with ten 3.5 mm holes. A matte acetal buckle with nonmetal retention and a silicone keeper are proposed. No exposed steel pin is specified. Corrosion resistance is required; UV-stabilized resin grade, latch strength, creep, attachment and saltwater durability remain unvalidated. Silicone elasticity supplements mechanical adjustment. Supported wearer ranges are not established.</a:t>
             </a:r>
           </a:p>
           <a:p xmlns:a="http://schemas.openxmlformats.org/drawingml/2006/main">
@@ -1411,7 +1411,7 @@
   </p:cSld>
   <p:clrMap bg1="lt1" tx1="dk1" bg2="lt2" tx2="dk2" accent1="accent1" accent2="accent2" accent3="accent3" accent4="accent4" accent5="accent5" accent6="accent6" hlink="hlink" folHlink="folHlink"/>
   <p:sldLayoutIdLst>
-    <p:sldLayoutId xmlns:r="http://schemas.openxmlformats.org/officeDocument/2006/relationships" id="2147483649" r:id="Rb5d393187ed54bfb"/>
+    <p:sldLayoutId xmlns:r="http://schemas.openxmlformats.org/officeDocument/2006/relationships" id="2147483649" r:id="Re554b1b1054a4da9"/>
   </p:sldLayoutIdLst>
   <p:txStyles>
     <p:titleStyle>
@@ -1962,7 +1962,7 @@
           <p:cNvPr id="6" name="">
             <a:extLst xmlns:a="http://schemas.openxmlformats.org/drawingml/2006/main">
               <a:ext uri="{FF2B5EF4-FFF2-40B4-BE49-F238E27FC236}">
-                <a16:creationId xmlns:a16="http://schemas.microsoft.com/office/drawing/2014/main" id="{1A43D74B-F40D-4344-941D-94A214540F74}"/>
+                <a16:creationId xmlns:a16="http://schemas.microsoft.com/office/drawing/2014/main" id="{DE39C15F-DB35-4C06-8C88-D0FF1626FB50}"/>
               </a:ext>
             </a:extLst>
           </p:cNvPr>
@@ -2042,7 +2042,7 @@
           <p:cNvPr id="2" name="">
             <a:extLst xmlns:a="http://schemas.openxmlformats.org/drawingml/2006/main">
               <a:ext uri="{FF2B5EF4-FFF2-40B4-BE49-F238E27FC236}">
-                <a16:creationId xmlns:a16="http://schemas.microsoft.com/office/drawing/2014/main" id="{76B8F910-92DD-4888-8C7D-5E718DA2AC07}"/>
+                <a16:creationId xmlns:a16="http://schemas.microsoft.com/office/drawing/2014/main" id="{5854A727-8A16-47CF-B073-A7A1179AB540}"/>
               </a:ext>
             </a:extLst>
           </p:cNvPr>
@@ -2122,7 +2122,7 @@
           <p:cNvPr id="3" name="">
             <a:extLst xmlns:a="http://schemas.openxmlformats.org/drawingml/2006/main">
               <a:ext uri="{FF2B5EF4-FFF2-40B4-BE49-F238E27FC236}">
-                <a16:creationId xmlns:a16="http://schemas.microsoft.com/office/drawing/2014/main" id="{98F4A0AA-9622-4D55-8E0C-B5F1C450C689}"/>
+                <a16:creationId xmlns:a16="http://schemas.microsoft.com/office/drawing/2014/main" id="{DD2F83E0-9983-49D6-B17D-947EF539EBCB}"/>
               </a:ext>
             </a:extLst>
           </p:cNvPr>
@@ -2183,7 +2183,7 @@
           <p:nvPr/>
         </p:nvPicPr>
         <p:blipFill>
-          <a:blip xmlns:r="http://schemas.openxmlformats.org/officeDocument/2006/relationships" xmlns:a="http://schemas.openxmlformats.org/drawingml/2006/main" r:embed="R7a4422b3a30b4234"/>
+          <a:blip xmlns:r="http://schemas.openxmlformats.org/officeDocument/2006/relationships" xmlns:a="http://schemas.openxmlformats.org/drawingml/2006/main" r:embed="R155c0b40960d4bab"/>
           <a:stretch xmlns:a="http://schemas.openxmlformats.org/drawingml/2006/main"/>
         </p:blipFill>
         <p:spPr>
@@ -2201,7 +2201,7 @@
           <p:cNvPr id="5" name="">
             <a:extLst xmlns:a="http://schemas.openxmlformats.org/drawingml/2006/main">
               <a:ext uri="{FF2B5EF4-FFF2-40B4-BE49-F238E27FC236}">
-                <a16:creationId xmlns:a16="http://schemas.microsoft.com/office/drawing/2014/main" id="{BF2CDBC9-C063-4922-9364-613614D9740A}"/>
+                <a16:creationId xmlns:a16="http://schemas.microsoft.com/office/drawing/2014/main" id="{89646594-B8C9-41FF-B2C5-DF06B581D319}"/>
               </a:ext>
             </a:extLst>
           </p:cNvPr>
@@ -2256,7 +2256,7 @@
     </p:spTree>
     <p:extLst>
       <p:ext uri="{BB962C8B-B14F-4D97-AF65-F5344CB8AC3E}">
-        <p14:creationId xmlns:p14="http://schemas.microsoft.com/office/powerpoint/2010/main" val="1116291267"/>
+        <p14:creationId xmlns:p14="http://schemas.microsoft.com/office/powerpoint/2010/main" val="2110396613"/>
       </p:ext>
     </p:extLst>
   </p:cSld>
@@ -2287,7 +2287,7 @@
           <p:cNvPr id="7" name="">
             <a:extLst xmlns:a="http://schemas.openxmlformats.org/drawingml/2006/main">
               <a:ext uri="{FF2B5EF4-FFF2-40B4-BE49-F238E27FC236}">
-                <a16:creationId xmlns:a16="http://schemas.microsoft.com/office/drawing/2014/main" id="{D94DEAA7-3215-4E67-A838-8C94B7A08510}"/>
+                <a16:creationId xmlns:a16="http://schemas.microsoft.com/office/drawing/2014/main" id="{2F26DABF-D09D-456A-B8E5-E69B127574B5}"/>
               </a:ext>
             </a:extLst>
           </p:cNvPr>
@@ -2367,7 +2367,7 @@
           <p:cNvPr id="2" name="">
             <a:extLst xmlns:a="http://schemas.openxmlformats.org/drawingml/2006/main">
               <a:ext uri="{FF2B5EF4-FFF2-40B4-BE49-F238E27FC236}">
-                <a16:creationId xmlns:a16="http://schemas.microsoft.com/office/drawing/2014/main" id="{1C5CA9DA-9FFF-4564-97F9-7C71CE296685}"/>
+                <a16:creationId xmlns:a16="http://schemas.microsoft.com/office/drawing/2014/main" id="{4654FE7F-D361-4B2D-8DCB-EE974589DF4D}"/>
               </a:ext>
             </a:extLst>
           </p:cNvPr>
@@ -2424,7 +2424,7 @@
           <p:cNvPr id="3" name="">
             <a:extLst xmlns:a="http://schemas.openxmlformats.org/drawingml/2006/main">
               <a:ext uri="{FF2B5EF4-FFF2-40B4-BE49-F238E27FC236}">
-                <a16:creationId xmlns:a16="http://schemas.microsoft.com/office/drawing/2014/main" id="{70951093-F831-495A-8D21-C0EF8D18650C}"/>
+                <a16:creationId xmlns:a16="http://schemas.microsoft.com/office/drawing/2014/main" id="{8A0D4037-D0A2-43EA-A2E1-C58BFBF241FC}"/>
               </a:ext>
             </a:extLst>
           </p:cNvPr>
@@ -2481,7 +2481,7 @@
           <p:cNvPr id="4" name="">
             <a:extLst xmlns:a="http://schemas.openxmlformats.org/drawingml/2006/main">
               <a:ext uri="{FF2B5EF4-FFF2-40B4-BE49-F238E27FC236}">
-                <a16:creationId xmlns:a16="http://schemas.microsoft.com/office/drawing/2014/main" id="{FA136D06-7B70-434D-AE1A-96585AD37E78}"/>
+                <a16:creationId xmlns:a16="http://schemas.microsoft.com/office/drawing/2014/main" id="{A9091631-E77C-4B4A-B445-89129B08D4FE}"/>
               </a:ext>
             </a:extLst>
           </p:cNvPr>
@@ -2588,7 +2588,7 @@
           <p:nvPr/>
         </p:nvPicPr>
         <p:blipFill>
-          <a:blip xmlns:r="http://schemas.openxmlformats.org/officeDocument/2006/relationships" xmlns:a="http://schemas.openxmlformats.org/drawingml/2006/main" r:embed="Rd50bf098af784aee"/>
+          <a:blip xmlns:r="http://schemas.openxmlformats.org/officeDocument/2006/relationships" xmlns:a="http://schemas.openxmlformats.org/drawingml/2006/main" r:embed="R47ac423e21c64950"/>
           <a:stretch xmlns:a="http://schemas.openxmlformats.org/drawingml/2006/main"/>
         </p:blipFill>
         <p:spPr>
@@ -2606,7 +2606,7 @@
           <p:cNvPr id="6" name="">
             <a:extLst xmlns:a="http://schemas.openxmlformats.org/drawingml/2006/main">
               <a:ext uri="{FF2B5EF4-FFF2-40B4-BE49-F238E27FC236}">
-                <a16:creationId xmlns:a16="http://schemas.microsoft.com/office/drawing/2014/main" id="{A36FA83F-06F6-4BFD-9DAE-8447B6A322D5}"/>
+                <a16:creationId xmlns:a16="http://schemas.microsoft.com/office/drawing/2014/main" id="{8AF6FCC2-1292-4135-BB05-F7E7FDB164FF}"/>
               </a:ext>
             </a:extLst>
           </p:cNvPr>
@@ -2661,7 +2661,7 @@
     </p:spTree>
     <p:extLst>
       <p:ext uri="{BB962C8B-B14F-4D97-AF65-F5344CB8AC3E}">
-        <p14:creationId xmlns:p14="http://schemas.microsoft.com/office/powerpoint/2010/main" val="379796778"/>
+        <p14:creationId xmlns:p14="http://schemas.microsoft.com/office/powerpoint/2010/main" val="1512686366"/>
       </p:ext>
     </p:extLst>
   </p:cSld>
@@ -2692,7 +2692,7 @@
           <p:cNvPr id="5" name="">
             <a:extLst xmlns:a="http://schemas.openxmlformats.org/drawingml/2006/main">
               <a:ext uri="{FF2B5EF4-FFF2-40B4-BE49-F238E27FC236}">
-                <a16:creationId xmlns:a16="http://schemas.microsoft.com/office/drawing/2014/main" id="{82C51592-72CC-4D19-8735-EB3D3BC38B3D}"/>
+                <a16:creationId xmlns:a16="http://schemas.microsoft.com/office/drawing/2014/main" id="{7731960D-C6D3-432D-95DD-F46873DF213A}"/>
               </a:ext>
             </a:extLst>
           </p:cNvPr>
@@ -2772,7 +2772,7 @@
           <p:cNvPr id="2" name="">
             <a:extLst xmlns:a="http://schemas.openxmlformats.org/drawingml/2006/main">
               <a:ext uri="{FF2B5EF4-FFF2-40B4-BE49-F238E27FC236}">
-                <a16:creationId xmlns:a16="http://schemas.microsoft.com/office/drawing/2014/main" id="{BA479CB8-D559-4317-BB01-C948F29E45DB}"/>
+                <a16:creationId xmlns:a16="http://schemas.microsoft.com/office/drawing/2014/main" id="{4AB8A3C6-E29E-4069-B820-DF5ACC3B56BF}"/>
               </a:ext>
             </a:extLst>
           </p:cNvPr>
@@ -2829,7 +2829,7 @@
           <p:cNvPr id="3" name="">
             <a:extLst xmlns:a="http://schemas.openxmlformats.org/drawingml/2006/main">
               <a:ext uri="{FF2B5EF4-FFF2-40B4-BE49-F238E27FC236}">
-                <a16:creationId xmlns:a16="http://schemas.microsoft.com/office/drawing/2014/main" id="{0F08E19C-B7C2-4B22-948D-14536FEE8216}"/>
+                <a16:creationId xmlns:a16="http://schemas.microsoft.com/office/drawing/2014/main" id="{AAFA8126-72B5-4BCD-BF47-75746FA4E811}"/>
               </a:ext>
             </a:extLst>
           </p:cNvPr>
@@ -2909,7 +2909,7 @@
           <p:cNvPr id="4" name="">
             <a:extLst xmlns:a="http://schemas.openxmlformats.org/drawingml/2006/main">
               <a:ext uri="{FF2B5EF4-FFF2-40B4-BE49-F238E27FC236}">
-                <a16:creationId xmlns:a16="http://schemas.microsoft.com/office/drawing/2014/main" id="{E2D23903-98C8-4FB3-82FA-FE54CA099B88}"/>
+                <a16:creationId xmlns:a16="http://schemas.microsoft.com/office/drawing/2014/main" id="{47D50D6F-D29D-4206-B1A9-B40CDE8C3F7C}"/>
               </a:ext>
             </a:extLst>
           </p:cNvPr>
@@ -2987,7 +2987,7 @@
     </p:spTree>
     <p:extLst>
       <p:ext uri="{BB962C8B-B14F-4D97-AF65-F5344CB8AC3E}">
-        <p14:creationId xmlns:p14="http://schemas.microsoft.com/office/powerpoint/2010/main" val="130652475"/>
+        <p14:creationId xmlns:p14="http://schemas.microsoft.com/office/powerpoint/2010/main" val="518591479"/>
       </p:ext>
     </p:extLst>
   </p:cSld>
@@ -3018,7 +3018,7 @@
           <p:cNvPr id="5" name="">
             <a:extLst xmlns:a="http://schemas.openxmlformats.org/drawingml/2006/main">
               <a:ext uri="{FF2B5EF4-FFF2-40B4-BE49-F238E27FC236}">
-                <a16:creationId xmlns:a16="http://schemas.microsoft.com/office/drawing/2014/main" id="{8F3B0CF8-7364-4BF2-AE5D-79D38D886BAB}"/>
+                <a16:creationId xmlns:a16="http://schemas.microsoft.com/office/drawing/2014/main" id="{44F53213-7A5A-49CC-BF03-13D04A4943C5}"/>
               </a:ext>
             </a:extLst>
           </p:cNvPr>
@@ -3098,7 +3098,7 @@
           <p:cNvPr id="2" name="">
             <a:extLst xmlns:a="http://schemas.openxmlformats.org/drawingml/2006/main">
               <a:ext uri="{FF2B5EF4-FFF2-40B4-BE49-F238E27FC236}">
-                <a16:creationId xmlns:a16="http://schemas.microsoft.com/office/drawing/2014/main" id="{A458E802-F949-4ED4-8912-87C04BD67ACA}"/>
+                <a16:creationId xmlns:a16="http://schemas.microsoft.com/office/drawing/2014/main" id="{3611AF2B-E807-40B4-87EB-1BA902A126E6}"/>
               </a:ext>
             </a:extLst>
           </p:cNvPr>
@@ -3178,7 +3178,7 @@
           <p:cNvPr id="3" name="">
             <a:extLst xmlns:a="http://schemas.openxmlformats.org/drawingml/2006/main">
               <a:ext uri="{FF2B5EF4-FFF2-40B4-BE49-F238E27FC236}">
-                <a16:creationId xmlns:a16="http://schemas.microsoft.com/office/drawing/2014/main" id="{9FCB3FF6-F4FA-4A35-9173-9C8E2B34E68F}"/>
+                <a16:creationId xmlns:a16="http://schemas.microsoft.com/office/drawing/2014/main" id="{A028444A-5DCF-4CD8-99FE-77E62A205273}"/>
               </a:ext>
             </a:extLst>
           </p:cNvPr>
@@ -3258,7 +3258,7 @@
           <p:cNvPr id="4" name="">
             <a:extLst xmlns:a="http://schemas.openxmlformats.org/drawingml/2006/main">
               <a:ext uri="{FF2B5EF4-FFF2-40B4-BE49-F238E27FC236}">
-                <a16:creationId xmlns:a16="http://schemas.microsoft.com/office/drawing/2014/main" id="{20565CE7-212A-450A-984D-A51F8AD92DC4}"/>
+                <a16:creationId xmlns:a16="http://schemas.microsoft.com/office/drawing/2014/main" id="{964EB649-7783-4B42-B136-52C345C8A213}"/>
               </a:ext>
             </a:extLst>
           </p:cNvPr>
@@ -3313,7 +3313,7 @@
     </p:spTree>
     <p:extLst>
       <p:ext uri="{BB962C8B-B14F-4D97-AF65-F5344CB8AC3E}">
-        <p14:creationId xmlns:p14="http://schemas.microsoft.com/office/powerpoint/2010/main" val="916796239"/>
+        <p14:creationId xmlns:p14="http://schemas.microsoft.com/office/powerpoint/2010/main" val="1660671051"/>
       </p:ext>
     </p:extLst>
   </p:cSld>
@@ -3344,7 +3344,7 @@
           <p:cNvPr id="5" name="">
             <a:extLst xmlns:a="http://schemas.openxmlformats.org/drawingml/2006/main">
               <a:ext uri="{FF2B5EF4-FFF2-40B4-BE49-F238E27FC236}">
-                <a16:creationId xmlns:a16="http://schemas.microsoft.com/office/drawing/2014/main" id="{A245E0CB-207E-406F-96CA-C9FF95100AB6}"/>
+                <a16:creationId xmlns:a16="http://schemas.microsoft.com/office/drawing/2014/main" id="{23E2493A-4233-44F0-B027-1FA4A1A16EBE}"/>
               </a:ext>
             </a:extLst>
           </p:cNvPr>
@@ -3424,7 +3424,7 @@
           <p:cNvPr id="2" name="">
             <a:extLst xmlns:a="http://schemas.openxmlformats.org/drawingml/2006/main">
               <a:ext uri="{FF2B5EF4-FFF2-40B4-BE49-F238E27FC236}">
-                <a16:creationId xmlns:a16="http://schemas.microsoft.com/office/drawing/2014/main" id="{6FA33AE0-575D-4A27-A64F-20A2EE97FD8B}"/>
+                <a16:creationId xmlns:a16="http://schemas.microsoft.com/office/drawing/2014/main" id="{8423B221-E513-4122-A573-4C104D01BACB}"/>
               </a:ext>
             </a:extLst>
           </p:cNvPr>
@@ -3504,7 +3504,7 @@
           <p:cNvPr id="3" name="">
             <a:extLst xmlns:a="http://schemas.openxmlformats.org/drawingml/2006/main">
               <a:ext uri="{FF2B5EF4-FFF2-40B4-BE49-F238E27FC236}">
-                <a16:creationId xmlns:a16="http://schemas.microsoft.com/office/drawing/2014/main" id="{397FFBED-5476-4E99-BF0F-4D869F7DC829}"/>
+                <a16:creationId xmlns:a16="http://schemas.microsoft.com/office/drawing/2014/main" id="{1007131E-26A6-401B-A897-E2B97ED5FEF8}"/>
               </a:ext>
             </a:extLst>
           </p:cNvPr>
@@ -3584,7 +3584,7 @@
           <p:cNvPr id="4" name="">
             <a:extLst xmlns:a="http://schemas.openxmlformats.org/drawingml/2006/main">
               <a:ext uri="{FF2B5EF4-FFF2-40B4-BE49-F238E27FC236}">
-                <a16:creationId xmlns:a16="http://schemas.microsoft.com/office/drawing/2014/main" id="{1BF40026-C1DF-4D47-85AD-A0822EAEFBD1}"/>
+                <a16:creationId xmlns:a16="http://schemas.microsoft.com/office/drawing/2014/main" id="{1C110B8B-C6BC-42A6-8E89-54F94C2A9881}"/>
               </a:ext>
             </a:extLst>
           </p:cNvPr>
@@ -3639,7 +3639,7 @@
     </p:spTree>
     <p:extLst>
       <p:ext uri="{BB962C8B-B14F-4D97-AF65-F5344CB8AC3E}">
-        <p14:creationId xmlns:p14="http://schemas.microsoft.com/office/powerpoint/2010/main" val="1828516451"/>
+        <p14:creationId xmlns:p14="http://schemas.microsoft.com/office/powerpoint/2010/main" val="613121401"/>
       </p:ext>
     </p:extLst>
   </p:cSld>
@@ -3670,7 +3670,7 @@
           <p:cNvPr id="7" name="">
             <a:extLst xmlns:a="http://schemas.openxmlformats.org/drawingml/2006/main">
               <a:ext uri="{FF2B5EF4-FFF2-40B4-BE49-F238E27FC236}">
-                <a16:creationId xmlns:a16="http://schemas.microsoft.com/office/drawing/2014/main" id="{49F7DEBB-1F53-49D3-9240-5CB30196DB38}"/>
+                <a16:creationId xmlns:a16="http://schemas.microsoft.com/office/drawing/2014/main" id="{A2327635-CB82-4B11-8580-2815A903A21F}"/>
               </a:ext>
             </a:extLst>
           </p:cNvPr>
@@ -3750,7 +3750,7 @@
           <p:cNvPr id="2" name="">
             <a:extLst xmlns:a="http://schemas.openxmlformats.org/drawingml/2006/main">
               <a:ext uri="{FF2B5EF4-FFF2-40B4-BE49-F238E27FC236}">
-                <a16:creationId xmlns:a16="http://schemas.microsoft.com/office/drawing/2014/main" id="{5D3AA3A9-E932-48C9-A561-8D51F68CB52E}"/>
+                <a16:creationId xmlns:a16="http://schemas.microsoft.com/office/drawing/2014/main" id="{DA0F1436-192F-46E4-AF11-7C0101F4B786}"/>
               </a:ext>
             </a:extLst>
           </p:cNvPr>
@@ -3807,7 +3807,7 @@
           <p:cNvPr id="3" name="">
             <a:extLst xmlns:a="http://schemas.openxmlformats.org/drawingml/2006/main">
               <a:ext uri="{FF2B5EF4-FFF2-40B4-BE49-F238E27FC236}">
-                <a16:creationId xmlns:a16="http://schemas.microsoft.com/office/drawing/2014/main" id="{764DED05-0185-4D11-984C-6661861E77DA}"/>
+                <a16:creationId xmlns:a16="http://schemas.microsoft.com/office/drawing/2014/main" id="{4E2E106C-721E-401A-8A3D-487E4D33F13C}"/>
               </a:ext>
             </a:extLst>
           </p:cNvPr>
@@ -3910,7 +3910,7 @@
           <p:cNvPr id="4" name="">
             <a:extLst xmlns:a="http://schemas.openxmlformats.org/drawingml/2006/main">
               <a:ext uri="{FF2B5EF4-FFF2-40B4-BE49-F238E27FC236}">
-                <a16:creationId xmlns:a16="http://schemas.microsoft.com/office/drawing/2014/main" id="{CFD4E409-2ABC-4C7B-B62B-8DAB513993CC}"/>
+                <a16:creationId xmlns:a16="http://schemas.microsoft.com/office/drawing/2014/main" id="{3DB08337-A5CB-4EC0-A36A-9713BE85B66C}"/>
               </a:ext>
             </a:extLst>
           </p:cNvPr>
@@ -3967,7 +3967,7 @@
           <p:cNvPr id="5" name="">
             <a:extLst xmlns:a="http://schemas.openxmlformats.org/drawingml/2006/main">
               <a:ext uri="{FF2B5EF4-FFF2-40B4-BE49-F238E27FC236}">
-                <a16:creationId xmlns:a16="http://schemas.microsoft.com/office/drawing/2014/main" id="{7EAFA9A0-C961-423B-9176-B3B9DA4C2B81}"/>
+                <a16:creationId xmlns:a16="http://schemas.microsoft.com/office/drawing/2014/main" id="{33CBAA3A-6096-447C-94AC-6D31972E4A50}"/>
               </a:ext>
             </a:extLst>
           </p:cNvPr>
@@ -4070,7 +4070,7 @@
           <p:cNvPr id="6" name="">
             <a:extLst xmlns:a="http://schemas.openxmlformats.org/drawingml/2006/main">
               <a:ext uri="{FF2B5EF4-FFF2-40B4-BE49-F238E27FC236}">
-                <a16:creationId xmlns:a16="http://schemas.microsoft.com/office/drawing/2014/main" id="{CD9B456A-AA5C-46AA-B99B-5D1B188EAF4E}"/>
+                <a16:creationId xmlns:a16="http://schemas.microsoft.com/office/drawing/2014/main" id="{6C92655C-93B1-40B8-A5A0-B9B891C8476D}"/>
               </a:ext>
             </a:extLst>
           </p:cNvPr>
@@ -4125,7 +4125,7 @@
     </p:spTree>
     <p:extLst>
       <p:ext uri="{BB962C8B-B14F-4D97-AF65-F5344CB8AC3E}">
-        <p14:creationId xmlns:p14="http://schemas.microsoft.com/office/powerpoint/2010/main" val="1456466672"/>
+        <p14:creationId xmlns:p14="http://schemas.microsoft.com/office/powerpoint/2010/main" val="140495266"/>
       </p:ext>
     </p:extLst>
   </p:cSld>
@@ -4156,7 +4156,7 @@
           <p:cNvPr id="19" name="">
             <a:extLst xmlns:a="http://schemas.openxmlformats.org/drawingml/2006/main">
               <a:ext uri="{FF2B5EF4-FFF2-40B4-BE49-F238E27FC236}">
-                <a16:creationId xmlns:a16="http://schemas.microsoft.com/office/drawing/2014/main" id="{5199F70C-DD95-4AD0-B55D-6DF2F59C58DA}"/>
+                <a16:creationId xmlns:a16="http://schemas.microsoft.com/office/drawing/2014/main" id="{5BDDF5BF-AB7C-4FB4-B520-7B69D95DD4E4}"/>
               </a:ext>
             </a:extLst>
           </p:cNvPr>
@@ -4236,7 +4236,7 @@
           <p:cNvPr id="2" name="">
             <a:extLst xmlns:a="http://schemas.openxmlformats.org/drawingml/2006/main">
               <a:ext uri="{FF2B5EF4-FFF2-40B4-BE49-F238E27FC236}">
-                <a16:creationId xmlns:a16="http://schemas.microsoft.com/office/drawing/2014/main" id="{48AE783E-614C-4EAC-A1B8-22B305CAFCFD}"/>
+                <a16:creationId xmlns:a16="http://schemas.microsoft.com/office/drawing/2014/main" id="{8EE2B2F6-4810-44BC-A522-56FDE36B91F6}"/>
               </a:ext>
             </a:extLst>
           </p:cNvPr>
@@ -4268,7 +4268,7 @@
           <p:cNvPr id="3" name="">
             <a:extLst xmlns:a="http://schemas.openxmlformats.org/drawingml/2006/main">
               <a:ext uri="{FF2B5EF4-FFF2-40B4-BE49-F238E27FC236}">
-                <a16:creationId xmlns:a16="http://schemas.microsoft.com/office/drawing/2014/main" id="{8754F181-B633-44A9-9C8D-65FBD770AE0A}"/>
+                <a16:creationId xmlns:a16="http://schemas.microsoft.com/office/drawing/2014/main" id="{761B28EC-31C8-4216-92AF-FE281F567E02}"/>
               </a:ext>
             </a:extLst>
           </p:cNvPr>
@@ -4325,7 +4325,7 @@
           <p:cNvPr id="4" name="">
             <a:extLst xmlns:a="http://schemas.openxmlformats.org/drawingml/2006/main">
               <a:ext uri="{FF2B5EF4-FFF2-40B4-BE49-F238E27FC236}">
-                <a16:creationId xmlns:a16="http://schemas.microsoft.com/office/drawing/2014/main" id="{86D82404-F43A-4DF3-995F-120BB04B9581}"/>
+                <a16:creationId xmlns:a16="http://schemas.microsoft.com/office/drawing/2014/main" id="{FD6DE3C6-4C58-4F00-AC80-72BCA4CF4E57}"/>
               </a:ext>
             </a:extLst>
           </p:cNvPr>
@@ -4382,7 +4382,7 @@
           <p:cNvPr id="5" name="">
             <a:extLst xmlns:a="http://schemas.openxmlformats.org/drawingml/2006/main">
               <a:ext uri="{FF2B5EF4-FFF2-40B4-BE49-F238E27FC236}">
-                <a16:creationId xmlns:a16="http://schemas.microsoft.com/office/drawing/2014/main" id="{098E82A6-E331-40B1-915A-F39A1FA3ED21}"/>
+                <a16:creationId xmlns:a16="http://schemas.microsoft.com/office/drawing/2014/main" id="{759CE0D3-24D6-4C74-A362-3C50B74F0637}"/>
               </a:ext>
             </a:extLst>
           </p:cNvPr>
@@ -4439,7 +4439,7 @@
           <p:cNvPr id="6" name="">
             <a:extLst xmlns:a="http://schemas.openxmlformats.org/drawingml/2006/main">
               <a:ext uri="{FF2B5EF4-FFF2-40B4-BE49-F238E27FC236}">
-                <a16:creationId xmlns:a16="http://schemas.microsoft.com/office/drawing/2014/main" id="{7E34DF40-7380-4D57-BA72-F28DCA6D7BE4}"/>
+                <a16:creationId xmlns:a16="http://schemas.microsoft.com/office/drawing/2014/main" id="{499A9B5A-739F-440D-8EFA-7014EA45A8BF}"/>
               </a:ext>
             </a:extLst>
           </p:cNvPr>
@@ -4496,7 +4496,7 @@
           <p:cNvPr id="7" name="">
             <a:extLst xmlns:a="http://schemas.openxmlformats.org/drawingml/2006/main">
               <a:ext uri="{FF2B5EF4-FFF2-40B4-BE49-F238E27FC236}">
-                <a16:creationId xmlns:a16="http://schemas.microsoft.com/office/drawing/2014/main" id="{77099D48-C15C-4432-B3E1-8353A3BD930F}"/>
+                <a16:creationId xmlns:a16="http://schemas.microsoft.com/office/drawing/2014/main" id="{2A9C2BF7-34DB-47A1-85E5-F52CB1D7F33F}"/>
               </a:ext>
             </a:extLst>
           </p:cNvPr>
@@ -4528,7 +4528,7 @@
           <p:cNvPr id="8" name="">
             <a:extLst xmlns:a="http://schemas.openxmlformats.org/drawingml/2006/main">
               <a:ext uri="{FF2B5EF4-FFF2-40B4-BE49-F238E27FC236}">
-                <a16:creationId xmlns:a16="http://schemas.microsoft.com/office/drawing/2014/main" id="{4B2E053C-E919-4FCD-874B-9FB44EEB9170}"/>
+                <a16:creationId xmlns:a16="http://schemas.microsoft.com/office/drawing/2014/main" id="{C6E3497D-7E65-4CFF-A17C-E9E96D6E2FBE}"/>
               </a:ext>
             </a:extLst>
           </p:cNvPr>
@@ -4585,7 +4585,7 @@
           <p:cNvPr id="9" name="">
             <a:extLst xmlns:a="http://schemas.openxmlformats.org/drawingml/2006/main">
               <a:ext uri="{FF2B5EF4-FFF2-40B4-BE49-F238E27FC236}">
-                <a16:creationId xmlns:a16="http://schemas.microsoft.com/office/drawing/2014/main" id="{EA01C18E-DBBC-4C7B-87B4-9173A1A127DA}"/>
+                <a16:creationId xmlns:a16="http://schemas.microsoft.com/office/drawing/2014/main" id="{ABC9F057-A5BD-4EAD-9126-7B8B17AA1552}"/>
               </a:ext>
             </a:extLst>
           </p:cNvPr>
@@ -4642,7 +4642,7 @@
           <p:cNvPr id="10" name="">
             <a:extLst xmlns:a="http://schemas.openxmlformats.org/drawingml/2006/main">
               <a:ext uri="{FF2B5EF4-FFF2-40B4-BE49-F238E27FC236}">
-                <a16:creationId xmlns:a16="http://schemas.microsoft.com/office/drawing/2014/main" id="{BFDD6262-2081-42FE-9E47-FD3D73291293}"/>
+                <a16:creationId xmlns:a16="http://schemas.microsoft.com/office/drawing/2014/main" id="{FF139E00-BF8F-4495-88D9-19842473975D}"/>
               </a:ext>
             </a:extLst>
           </p:cNvPr>
@@ -4699,7 +4699,7 @@
           <p:cNvPr id="11" name="">
             <a:extLst xmlns:a="http://schemas.openxmlformats.org/drawingml/2006/main">
               <a:ext uri="{FF2B5EF4-FFF2-40B4-BE49-F238E27FC236}">
-                <a16:creationId xmlns:a16="http://schemas.microsoft.com/office/drawing/2014/main" id="{E66EDD2D-B21F-4760-A5D5-6DE1864D4FE7}"/>
+                <a16:creationId xmlns:a16="http://schemas.microsoft.com/office/drawing/2014/main" id="{F7ED504E-EEED-4F38-99B0-AC1D91D55AB3}"/>
               </a:ext>
             </a:extLst>
           </p:cNvPr>
@@ -4756,7 +4756,7 @@
           <p:cNvPr id="12" name="">
             <a:extLst xmlns:a="http://schemas.openxmlformats.org/drawingml/2006/main">
               <a:ext uri="{FF2B5EF4-FFF2-40B4-BE49-F238E27FC236}">
-                <a16:creationId xmlns:a16="http://schemas.microsoft.com/office/drawing/2014/main" id="{0901F82F-2E75-482B-8B05-A069EC5B0F73}"/>
+                <a16:creationId xmlns:a16="http://schemas.microsoft.com/office/drawing/2014/main" id="{A77EA953-C21C-4573-A7E6-E83BD3D9ECC0}"/>
               </a:ext>
             </a:extLst>
           </p:cNvPr>
@@ -4788,7 +4788,7 @@
           <p:cNvPr id="13" name="">
             <a:extLst xmlns:a="http://schemas.openxmlformats.org/drawingml/2006/main">
               <a:ext uri="{FF2B5EF4-FFF2-40B4-BE49-F238E27FC236}">
-                <a16:creationId xmlns:a16="http://schemas.microsoft.com/office/drawing/2014/main" id="{E8D95F5A-06AB-47EA-9F93-D215C94BDC53}"/>
+                <a16:creationId xmlns:a16="http://schemas.microsoft.com/office/drawing/2014/main" id="{02167035-F117-4D42-B986-26123AE243C1}"/>
               </a:ext>
             </a:extLst>
           </p:cNvPr>
@@ -4845,7 +4845,7 @@
           <p:cNvPr id="14" name="">
             <a:extLst xmlns:a="http://schemas.openxmlformats.org/drawingml/2006/main">
               <a:ext uri="{FF2B5EF4-FFF2-40B4-BE49-F238E27FC236}">
-                <a16:creationId xmlns:a16="http://schemas.microsoft.com/office/drawing/2014/main" id="{37CF5864-FE44-4E53-ADA1-ACC6B0A8544A}"/>
+                <a16:creationId xmlns:a16="http://schemas.microsoft.com/office/drawing/2014/main" id="{16557395-BA83-4104-8039-B1B2D2BA2F96}"/>
               </a:ext>
             </a:extLst>
           </p:cNvPr>
@@ -4902,7 +4902,7 @@
           <p:cNvPr id="15" name="">
             <a:extLst xmlns:a="http://schemas.openxmlformats.org/drawingml/2006/main">
               <a:ext uri="{FF2B5EF4-FFF2-40B4-BE49-F238E27FC236}">
-                <a16:creationId xmlns:a16="http://schemas.microsoft.com/office/drawing/2014/main" id="{2BD7C97D-FFAB-44AD-973A-3AEB94A251C8}"/>
+                <a16:creationId xmlns:a16="http://schemas.microsoft.com/office/drawing/2014/main" id="{65A33D4F-B786-48B4-8485-9214F45484CA}"/>
               </a:ext>
             </a:extLst>
           </p:cNvPr>
@@ -4959,7 +4959,7 @@
           <p:cNvPr id="16" name="">
             <a:extLst xmlns:a="http://schemas.openxmlformats.org/drawingml/2006/main">
               <a:ext uri="{FF2B5EF4-FFF2-40B4-BE49-F238E27FC236}">
-                <a16:creationId xmlns:a16="http://schemas.microsoft.com/office/drawing/2014/main" id="{AE2CFF8A-4FA3-44A2-9A4C-A7F0C4A31038}"/>
+                <a16:creationId xmlns:a16="http://schemas.microsoft.com/office/drawing/2014/main" id="{745169EB-7662-463B-A038-3DB5A91DE7D2}"/>
               </a:ext>
             </a:extLst>
           </p:cNvPr>
@@ -5016,7 +5016,7 @@
           <p:cNvPr id="17" name="">
             <a:extLst xmlns:a="http://schemas.openxmlformats.org/drawingml/2006/main">
               <a:ext uri="{FF2B5EF4-FFF2-40B4-BE49-F238E27FC236}">
-                <a16:creationId xmlns:a16="http://schemas.microsoft.com/office/drawing/2014/main" id="{8A9962EE-325B-4641-B1E0-68882BB04EAE}"/>
+                <a16:creationId xmlns:a16="http://schemas.microsoft.com/office/drawing/2014/main" id="{6E664D66-3801-4CA0-ABDE-3C6A56B6632E}"/>
               </a:ext>
             </a:extLst>
           </p:cNvPr>
@@ -5096,7 +5096,7 @@
           <p:cNvPr id="18" name="">
             <a:extLst xmlns:a="http://schemas.openxmlformats.org/drawingml/2006/main">
               <a:ext uri="{FF2B5EF4-FFF2-40B4-BE49-F238E27FC236}">
-                <a16:creationId xmlns:a16="http://schemas.microsoft.com/office/drawing/2014/main" id="{3E65DA71-F701-4C64-9F3C-CBB0A65764F9}"/>
+                <a16:creationId xmlns:a16="http://schemas.microsoft.com/office/drawing/2014/main" id="{FD229A42-71F5-4974-AD1C-631D194C7180}"/>
               </a:ext>
             </a:extLst>
           </p:cNvPr>
@@ -5151,7 +5151,7 @@
     </p:spTree>
     <p:extLst>
       <p:ext uri="{BB962C8B-B14F-4D97-AF65-F5344CB8AC3E}">
-        <p14:creationId xmlns:p14="http://schemas.microsoft.com/office/powerpoint/2010/main" val="242028648"/>
+        <p14:creationId xmlns:p14="http://schemas.microsoft.com/office/powerpoint/2010/main" val="2074614446"/>
       </p:ext>
     </p:extLst>
   </p:cSld>
@@ -5182,7 +5182,7 @@
           <p:cNvPr id="6" name="">
             <a:extLst xmlns:a="http://schemas.openxmlformats.org/drawingml/2006/main">
               <a:ext uri="{FF2B5EF4-FFF2-40B4-BE49-F238E27FC236}">
-                <a16:creationId xmlns:a16="http://schemas.microsoft.com/office/drawing/2014/main" id="{61B49D56-C9CC-4B57-B238-8B925B636C3E}"/>
+                <a16:creationId xmlns:a16="http://schemas.microsoft.com/office/drawing/2014/main" id="{5949D2B0-FADE-4A78-A14D-6FE16649C24A}"/>
               </a:ext>
             </a:extLst>
           </p:cNvPr>
@@ -5243,7 +5243,7 @@
           <p:nvPr/>
         </p:nvPicPr>
         <p:blipFill>
-          <a:blip xmlns:r="http://schemas.openxmlformats.org/officeDocument/2006/relationships" xmlns:a="http://schemas.openxmlformats.org/drawingml/2006/main" r:embed="Rbf8f7ce9034d4c7e"/>
+          <a:blip xmlns:r="http://schemas.openxmlformats.org/officeDocument/2006/relationships" xmlns:a="http://schemas.openxmlformats.org/drawingml/2006/main" r:embed="Re5a3f39aa02f4e10"/>
           <a:stretch xmlns:a="http://schemas.openxmlformats.org/drawingml/2006/main"/>
         </p:blipFill>
         <p:spPr>
@@ -5265,7 +5265,7 @@
           <p:nvPr/>
         </p:nvPicPr>
         <p:blipFill>
-          <a:blip xmlns:r="http://schemas.openxmlformats.org/officeDocument/2006/relationships" xmlns:a="http://schemas.openxmlformats.org/drawingml/2006/main" r:embed="Re518bf93e1934499"/>
+          <a:blip xmlns:r="http://schemas.openxmlformats.org/officeDocument/2006/relationships" xmlns:a="http://schemas.openxmlformats.org/drawingml/2006/main" r:embed="R5e3a0ca368a8460f"/>
           <a:stretch xmlns:a="http://schemas.openxmlformats.org/drawingml/2006/main"/>
         </p:blipFill>
         <p:spPr>
@@ -5283,7 +5283,7 @@
           <p:cNvPr id="4" name="">
             <a:extLst xmlns:a="http://schemas.openxmlformats.org/drawingml/2006/main">
               <a:ext uri="{FF2B5EF4-FFF2-40B4-BE49-F238E27FC236}">
-                <a16:creationId xmlns:a16="http://schemas.microsoft.com/office/drawing/2014/main" id="{1FF02851-B9FC-49F0-95C1-D5A9C96737C8}"/>
+                <a16:creationId xmlns:a16="http://schemas.microsoft.com/office/drawing/2014/main" id="{5C465B06-3BE3-478A-928C-132D2E5E06AF}"/>
               </a:ext>
             </a:extLst>
           </p:cNvPr>
@@ -5340,7 +5340,7 @@
           <p:cNvPr id="5" name="">
             <a:extLst xmlns:a="http://schemas.openxmlformats.org/drawingml/2006/main">
               <a:ext uri="{FF2B5EF4-FFF2-40B4-BE49-F238E27FC236}">
-                <a16:creationId xmlns:a16="http://schemas.microsoft.com/office/drawing/2014/main" id="{D3E7C493-3DF3-4760-83A9-31EDD9758716}"/>
+                <a16:creationId xmlns:a16="http://schemas.microsoft.com/office/drawing/2014/main" id="{2FEFE08D-6289-48C9-84B2-A938AEF581B3}"/>
               </a:ext>
             </a:extLst>
           </p:cNvPr>
@@ -5395,7 +5395,7 @@
     </p:spTree>
     <p:extLst>
       <p:ext uri="{BB962C8B-B14F-4D97-AF65-F5344CB8AC3E}">
-        <p14:creationId xmlns:p14="http://schemas.microsoft.com/office/powerpoint/2010/main" val="473259144"/>
+        <p14:creationId xmlns:p14="http://schemas.microsoft.com/office/powerpoint/2010/main" val="1109322595"/>
       </p:ext>
     </p:extLst>
   </p:cSld>
@@ -5426,7 +5426,7 @@
           <p:cNvPr id="6" name="">
             <a:extLst xmlns:a="http://schemas.openxmlformats.org/drawingml/2006/main">
               <a:ext uri="{FF2B5EF4-FFF2-40B4-BE49-F238E27FC236}">
-                <a16:creationId xmlns:a16="http://schemas.microsoft.com/office/drawing/2014/main" id="{EC428F74-55E8-484D-8031-D70A0AD3B11F}"/>
+                <a16:creationId xmlns:a16="http://schemas.microsoft.com/office/drawing/2014/main" id="{CD9F2AB8-F212-4107-A52A-FE4B33271A8C}"/>
               </a:ext>
             </a:extLst>
           </p:cNvPr>
@@ -5510,7 +5510,7 @@
           <p:nvPr/>
         </p:nvPicPr>
         <p:blipFill>
-          <a:blip xmlns:r="http://schemas.openxmlformats.org/officeDocument/2006/relationships" xmlns:a="http://schemas.openxmlformats.org/drawingml/2006/main" r:embed="R3480dfacd2f547c2"/>
+          <a:blip xmlns:r="http://schemas.openxmlformats.org/officeDocument/2006/relationships" xmlns:a="http://schemas.openxmlformats.org/drawingml/2006/main" r:embed="R5452643b71c14175"/>
           <a:stretch xmlns:a="http://schemas.openxmlformats.org/drawingml/2006/main"/>
         </p:blipFill>
         <p:spPr>
@@ -5528,7 +5528,7 @@
           <p:cNvPr id="3" name="">
             <a:extLst xmlns:a="http://schemas.openxmlformats.org/drawingml/2006/main">
               <a:ext uri="{FF2B5EF4-FFF2-40B4-BE49-F238E27FC236}">
-                <a16:creationId xmlns:a16="http://schemas.microsoft.com/office/drawing/2014/main" id="{557155DA-58F0-4BA2-85CC-6B4295AEEA9F}"/>
+                <a16:creationId xmlns:a16="http://schemas.microsoft.com/office/drawing/2014/main" id="{BE933CD2-43F0-4536-BC9C-9268782AC004}"/>
               </a:ext>
             </a:extLst>
           </p:cNvPr>
@@ -5631,7 +5631,7 @@
           <p:cNvPr id="4" name="">
             <a:extLst xmlns:a="http://schemas.openxmlformats.org/drawingml/2006/main">
               <a:ext uri="{FF2B5EF4-FFF2-40B4-BE49-F238E27FC236}">
-                <a16:creationId xmlns:a16="http://schemas.microsoft.com/office/drawing/2014/main" id="{6332E27E-35FF-4934-AB6D-CCBD6947A462}"/>
+                <a16:creationId xmlns:a16="http://schemas.microsoft.com/office/drawing/2014/main" id="{B06FF8DE-A112-46B8-94CE-BBF14FFDDEFE}"/>
               </a:ext>
             </a:extLst>
           </p:cNvPr>
@@ -5711,7 +5711,7 @@
           <p:cNvPr id="5" name="">
             <a:extLst xmlns:a="http://schemas.openxmlformats.org/drawingml/2006/main">
               <a:ext uri="{FF2B5EF4-FFF2-40B4-BE49-F238E27FC236}">
-                <a16:creationId xmlns:a16="http://schemas.microsoft.com/office/drawing/2014/main" id="{7EA754A8-10AA-44F0-9884-043D4501E407}"/>
+                <a16:creationId xmlns:a16="http://schemas.microsoft.com/office/drawing/2014/main" id="{BB6C3119-595E-488A-80B2-70C982948485}"/>
               </a:ext>
             </a:extLst>
           </p:cNvPr>
@@ -5766,7 +5766,7 @@
     </p:spTree>
     <p:extLst>
       <p:ext uri="{BB962C8B-B14F-4D97-AF65-F5344CB8AC3E}">
-        <p14:creationId xmlns:p14="http://schemas.microsoft.com/office/powerpoint/2010/main" val="838804294"/>
+        <p14:creationId xmlns:p14="http://schemas.microsoft.com/office/powerpoint/2010/main" val="475138123"/>
       </p:ext>
     </p:extLst>
   </p:cSld>
@@ -5797,7 +5797,7 @@
           <p:cNvPr id="8" name="">
             <a:extLst xmlns:a="http://schemas.openxmlformats.org/drawingml/2006/main">
               <a:ext uri="{FF2B5EF4-FFF2-40B4-BE49-F238E27FC236}">
-                <a16:creationId xmlns:a16="http://schemas.microsoft.com/office/drawing/2014/main" id="{729C6F9B-3D0C-4ACB-BBB9-5BACEE9204E6}"/>
+                <a16:creationId xmlns:a16="http://schemas.microsoft.com/office/drawing/2014/main" id="{9AB97510-F312-40A2-A269-E0F07F5D4674}"/>
               </a:ext>
             </a:extLst>
           </p:cNvPr>
@@ -5881,7 +5881,7 @@
           <p:nvPr/>
         </p:nvPicPr>
         <p:blipFill>
-          <a:blip xmlns:r="http://schemas.openxmlformats.org/officeDocument/2006/relationships" xmlns:a="http://schemas.openxmlformats.org/drawingml/2006/main" r:embed="R0b8f7fc2331e4122"/>
+          <a:blip xmlns:r="http://schemas.openxmlformats.org/officeDocument/2006/relationships" xmlns:a="http://schemas.openxmlformats.org/drawingml/2006/main" r:embed="R0fb51989e9434e68"/>
           <a:stretch xmlns:a="http://schemas.openxmlformats.org/drawingml/2006/main"/>
         </p:blipFill>
         <p:spPr>
@@ -5899,7 +5899,7 @@
           <p:cNvPr id="3" name="">
             <a:extLst xmlns:a="http://schemas.openxmlformats.org/drawingml/2006/main">
               <a:ext uri="{FF2B5EF4-FFF2-40B4-BE49-F238E27FC236}">
-                <a16:creationId xmlns:a16="http://schemas.microsoft.com/office/drawing/2014/main" id="{8489E727-7106-44F1-91B6-1BE724CFCFCF}"/>
+                <a16:creationId xmlns:a16="http://schemas.microsoft.com/office/drawing/2014/main" id="{6D6D3BCC-D0C3-4B4F-BFC5-C2C455DF360D}"/>
               </a:ext>
             </a:extLst>
           </p:cNvPr>
@@ -5956,7 +5956,7 @@
           <p:cNvPr id="4" name="">
             <a:extLst xmlns:a="http://schemas.openxmlformats.org/drawingml/2006/main">
               <a:ext uri="{FF2B5EF4-FFF2-40B4-BE49-F238E27FC236}">
-                <a16:creationId xmlns:a16="http://schemas.microsoft.com/office/drawing/2014/main" id="{57856666-B9CC-463F-912B-0993D2616372}"/>
+                <a16:creationId xmlns:a16="http://schemas.microsoft.com/office/drawing/2014/main" id="{628B9943-D249-4B09-A4FE-7BF91B7BAFA8}"/>
               </a:ext>
             </a:extLst>
           </p:cNvPr>
@@ -6013,7 +6013,7 @@
           <p:cNvPr id="5" name="">
             <a:extLst xmlns:a="http://schemas.openxmlformats.org/drawingml/2006/main">
               <a:ext uri="{FF2B5EF4-FFF2-40B4-BE49-F238E27FC236}">
-                <a16:creationId xmlns:a16="http://schemas.microsoft.com/office/drawing/2014/main" id="{1CF92103-669F-4232-9100-FB222DEB1387}"/>
+                <a16:creationId xmlns:a16="http://schemas.microsoft.com/office/drawing/2014/main" id="{EB3CCA45-0186-41C4-B8CB-4DD85AA1CFDF}"/>
               </a:ext>
             </a:extLst>
           </p:cNvPr>
@@ -6070,7 +6070,7 @@
           <p:cNvPr id="6" name="">
             <a:extLst xmlns:a="http://schemas.openxmlformats.org/drawingml/2006/main">
               <a:ext uri="{FF2B5EF4-FFF2-40B4-BE49-F238E27FC236}">
-                <a16:creationId xmlns:a16="http://schemas.microsoft.com/office/drawing/2014/main" id="{CBD29FC6-023A-4346-B374-ABF6BBC10267}"/>
+                <a16:creationId xmlns:a16="http://schemas.microsoft.com/office/drawing/2014/main" id="{CA9399EC-F7CC-4025-A425-BBE6B806CAC8}"/>
               </a:ext>
             </a:extLst>
           </p:cNvPr>
@@ -6127,7 +6127,7 @@
           <p:cNvPr id="7" name="">
             <a:extLst xmlns:a="http://schemas.openxmlformats.org/drawingml/2006/main">
               <a:ext uri="{FF2B5EF4-FFF2-40B4-BE49-F238E27FC236}">
-                <a16:creationId xmlns:a16="http://schemas.microsoft.com/office/drawing/2014/main" id="{837A8091-EF51-45BB-A606-EB65C74A2B3B}"/>
+                <a16:creationId xmlns:a16="http://schemas.microsoft.com/office/drawing/2014/main" id="{4CF83B56-0491-4A0A-9380-B5CC5FA3677E}"/>
               </a:ext>
             </a:extLst>
           </p:cNvPr>
@@ -6182,7 +6182,7 @@
     </p:spTree>
     <p:extLst>
       <p:ext uri="{BB962C8B-B14F-4D97-AF65-F5344CB8AC3E}">
-        <p14:creationId xmlns:p14="http://schemas.microsoft.com/office/powerpoint/2010/main" val="143222858"/>
+        <p14:creationId xmlns:p14="http://schemas.microsoft.com/office/powerpoint/2010/main" val="283134877"/>
       </p:ext>
     </p:extLst>
   </p:cSld>
@@ -6213,7 +6213,7 @@
           <p:cNvPr id="3" name="">
             <a:extLst xmlns:a="http://schemas.openxmlformats.org/drawingml/2006/main">
               <a:ext uri="{FF2B5EF4-FFF2-40B4-BE49-F238E27FC236}">
-                <a16:creationId xmlns:a16="http://schemas.microsoft.com/office/drawing/2014/main" id="{A37C46D6-F8AD-4D99-8AF0-C034EE325602}"/>
+                <a16:creationId xmlns:a16="http://schemas.microsoft.com/office/drawing/2014/main" id="{02D1BC2C-3B7A-40B3-B14A-29C8080FC7A0}"/>
               </a:ext>
             </a:extLst>
           </p:cNvPr>
@@ -6297,7 +6297,7 @@
           <p:nvPr/>
         </p:nvPicPr>
         <p:blipFill>
-          <a:blip xmlns:r="http://schemas.openxmlformats.org/officeDocument/2006/relationships" xmlns:a="http://schemas.openxmlformats.org/drawingml/2006/main" r:embed="Rc2f77f9f4d2e485d"/>
+          <a:blip xmlns:r="http://schemas.openxmlformats.org/officeDocument/2006/relationships" xmlns:a="http://schemas.openxmlformats.org/drawingml/2006/main" r:embed="Raec0cc55833c458f"/>
           <a:stretch xmlns:a="http://schemas.openxmlformats.org/drawingml/2006/main"/>
         </p:blipFill>
         <p:spPr>
@@ -6313,7 +6313,7 @@
     </p:spTree>
     <p:extLst>
       <p:ext uri="{BB962C8B-B14F-4D97-AF65-F5344CB8AC3E}">
-        <p14:creationId xmlns:p14="http://schemas.microsoft.com/office/powerpoint/2010/main" val="263721069"/>
+        <p14:creationId xmlns:p14="http://schemas.microsoft.com/office/powerpoint/2010/main" val="1836149954"/>
       </p:ext>
     </p:extLst>
   </p:cSld>
@@ -6344,7 +6344,7 @@
           <p:cNvPr id="5" name="">
             <a:extLst xmlns:a="http://schemas.openxmlformats.org/drawingml/2006/main">
               <a:ext uri="{FF2B5EF4-FFF2-40B4-BE49-F238E27FC236}">
-                <a16:creationId xmlns:a16="http://schemas.microsoft.com/office/drawing/2014/main" id="{70A7B767-485E-4206-B1EA-01D31C6365AA}"/>
+                <a16:creationId xmlns:a16="http://schemas.microsoft.com/office/drawing/2014/main" id="{FC4FA073-EEC5-4E31-B163-93EE2A916921}"/>
               </a:ext>
             </a:extLst>
           </p:cNvPr>
@@ -6424,7 +6424,7 @@
           <p:cNvPr id="2" name="">
             <a:extLst xmlns:a="http://schemas.openxmlformats.org/drawingml/2006/main">
               <a:ext uri="{FF2B5EF4-FFF2-40B4-BE49-F238E27FC236}">
-                <a16:creationId xmlns:a16="http://schemas.microsoft.com/office/drawing/2014/main" id="{5B921BB7-09C7-42AD-8547-70DA4667B643}"/>
+                <a16:creationId xmlns:a16="http://schemas.microsoft.com/office/drawing/2014/main" id="{765A49CC-1414-4D3C-8A84-CD7DC7A21689}"/>
               </a:ext>
             </a:extLst>
           </p:cNvPr>
@@ -6471,7 +6471,7 @@
                 <a:ea typeface="Helvetica Neue"/>
                 <a:cs typeface="Helvetica Neue"/>
               </a:rPr>
-              <a:t>Overlapping tail.</a:t>
+              <a:t>Adjustable silicone strap.</a:t>
             </a:r>
           </a:p>
           <a:p xmlns:a="http://schemas.openxmlformats.org/drawingml/2006/main">
@@ -6494,7 +6494,7 @@
                 <a:ea typeface="Helvetica Neue"/>
                 <a:cs typeface="Helvetica Neue"/>
               </a:rPr>
-              <a:t>Adjustment holes.</a:t>
+              <a:t>Matte acetal buckle.</a:t>
             </a:r>
           </a:p>
           <a:p xmlns:a="http://schemas.openxmlformats.org/drawingml/2006/main">
@@ -6517,7 +6517,7 @@
                 <a:ea typeface="Helvetica Neue"/>
                 <a:cs typeface="Helvetica Neue"/>
               </a:rPr>
-              <a:t>Buckle and keeper.</a:t>
+              <a:t>Silicone keeper.</a:t>
             </a:r>
           </a:p>
         </p:txBody>
@@ -6527,7 +6527,7 @@
           <p:cNvPr id="3" name="">
             <a:extLst xmlns:a="http://schemas.openxmlformats.org/drawingml/2006/main">
               <a:ext uri="{FF2B5EF4-FFF2-40B4-BE49-F238E27FC236}">
-                <a16:creationId xmlns:a16="http://schemas.microsoft.com/office/drawing/2014/main" id="{845C46FA-4999-4877-918C-287BA822BD88}"/>
+                <a16:creationId xmlns:a16="http://schemas.microsoft.com/office/drawing/2014/main" id="{BF1203CF-DC92-40A6-9048-73DB4FDB8FB6}"/>
               </a:ext>
             </a:extLst>
           </p:cNvPr>
@@ -6611,7 +6611,7 @@
           <p:nvPr/>
         </p:nvPicPr>
         <p:blipFill>
-          <a:blip xmlns:r="http://schemas.openxmlformats.org/officeDocument/2006/relationships" xmlns:a="http://schemas.openxmlformats.org/drawingml/2006/main" r:embed="R196fa50fdcd642b2"/>
+          <a:blip xmlns:r="http://schemas.openxmlformats.org/officeDocument/2006/relationships" xmlns:a="http://schemas.openxmlformats.org/drawingml/2006/main" r:embed="R55809fba390447be"/>
           <a:stretch xmlns:a="http://schemas.openxmlformats.org/drawingml/2006/main"/>
         </p:blipFill>
         <p:spPr>
@@ -6627,7 +6627,7 @@
     </p:spTree>
     <p:extLst>
       <p:ext uri="{BB962C8B-B14F-4D97-AF65-F5344CB8AC3E}">
-        <p14:creationId xmlns:p14="http://schemas.microsoft.com/office/powerpoint/2010/main" val="211701783"/>
+        <p14:creationId xmlns:p14="http://schemas.microsoft.com/office/powerpoint/2010/main" val="952670602"/>
       </p:ext>
     </p:extLst>
   </p:cSld>

</xml_diff>

<commit_message>
Credit The AI Doc for presentation strategy design and production
</commit_message>
<xml_diff>
--- a/DBA_Product_Overview_RevF.pptx
+++ b/DBA_Product_Overview_RevF.pptx
@@ -2,24 +2,24 @@
 <file path=ppt/presentation.xml><?xml version="1.0" encoding="utf-8"?>
 <p:presentation xmlns:p="http://schemas.openxmlformats.org/presentationml/2006/main">
   <p:sldMasterIdLst>
-    <p:sldMasterId xmlns:r="http://schemas.openxmlformats.org/officeDocument/2006/relationships" id="2147483648" r:id="R64b45ac822f54208"/>
+    <p:sldMasterId xmlns:r="http://schemas.openxmlformats.org/officeDocument/2006/relationships" id="2147483648" r:id="Rdf985933a9d64226"/>
   </p:sldMasterIdLst>
   <p:notesMasterIdLst>
-    <p:notesMasterId xmlns:r="http://schemas.openxmlformats.org/officeDocument/2006/relationships" r:id="Rd10e23bff1c14b1d"/>
+    <p:notesMasterId xmlns:r="http://schemas.openxmlformats.org/officeDocument/2006/relationships" r:id="R919f59b06d704cc2"/>
   </p:notesMasterIdLst>
   <p:sldIdLst>
-    <p:sldId xmlns:r="http://schemas.openxmlformats.org/officeDocument/2006/relationships" id="256" r:id="R4ce1cef5745b436a"/>
-    <p:sldId xmlns:r="http://schemas.openxmlformats.org/officeDocument/2006/relationships" id="257" r:id="R729abd53893149fe"/>
-    <p:sldId xmlns:r="http://schemas.openxmlformats.org/officeDocument/2006/relationships" id="258" r:id="Rae94467d73ef433c"/>
-    <p:sldId xmlns:r="http://schemas.openxmlformats.org/officeDocument/2006/relationships" id="259" r:id="R89c9360dd0354b73"/>
-    <p:sldId xmlns:r="http://schemas.openxmlformats.org/officeDocument/2006/relationships" id="260" r:id="R4f8cfd22c61945d1"/>
-    <p:sldId xmlns:r="http://schemas.openxmlformats.org/officeDocument/2006/relationships" id="261" r:id="R89c4f5acdafe4c52"/>
-    <p:sldId xmlns:r="http://schemas.openxmlformats.org/officeDocument/2006/relationships" id="262" r:id="R8d57a22d374a4064"/>
-    <p:sldId xmlns:r="http://schemas.openxmlformats.org/officeDocument/2006/relationships" id="263" r:id="Rd4752a7352f64919"/>
-    <p:sldId xmlns:r="http://schemas.openxmlformats.org/officeDocument/2006/relationships" id="264" r:id="Rcb07b83bf89844a6"/>
-    <p:sldId xmlns:r="http://schemas.openxmlformats.org/officeDocument/2006/relationships" id="265" r:id="Rfec9f3e198784536"/>
-    <p:sldId xmlns:r="http://schemas.openxmlformats.org/officeDocument/2006/relationships" id="266" r:id="Rba966e2cbc8844d3"/>
-    <p:sldId xmlns:r="http://schemas.openxmlformats.org/officeDocument/2006/relationships" id="267" r:id="Rd49145b647ce4649"/>
+    <p:sldId xmlns:r="http://schemas.openxmlformats.org/officeDocument/2006/relationships" id="256" r:id="Rffcd2e53edf44428"/>
+    <p:sldId xmlns:r="http://schemas.openxmlformats.org/officeDocument/2006/relationships" id="257" r:id="R78e54c768d8f4dcd"/>
+    <p:sldId xmlns:r="http://schemas.openxmlformats.org/officeDocument/2006/relationships" id="258" r:id="Rb87b105a07ca4ced"/>
+    <p:sldId xmlns:r="http://schemas.openxmlformats.org/officeDocument/2006/relationships" id="259" r:id="R415a834b8c9340c9"/>
+    <p:sldId xmlns:r="http://schemas.openxmlformats.org/officeDocument/2006/relationships" id="260" r:id="R890284294a8e4657"/>
+    <p:sldId xmlns:r="http://schemas.openxmlformats.org/officeDocument/2006/relationships" id="261" r:id="R0200186488e44020"/>
+    <p:sldId xmlns:r="http://schemas.openxmlformats.org/officeDocument/2006/relationships" id="262" r:id="R158a2d8594cd43dc"/>
+    <p:sldId xmlns:r="http://schemas.openxmlformats.org/officeDocument/2006/relationships" id="263" r:id="R38fc426e2cc14d40"/>
+    <p:sldId xmlns:r="http://schemas.openxmlformats.org/officeDocument/2006/relationships" id="264" r:id="Rf5a0617342584dc5"/>
+    <p:sldId xmlns:r="http://schemas.openxmlformats.org/officeDocument/2006/relationships" id="265" r:id="R84b800658b4945f0"/>
+    <p:sldId xmlns:r="http://schemas.openxmlformats.org/officeDocument/2006/relationships" id="266" r:id="Rece1114580f64d9b"/>
+    <p:sldId xmlns:r="http://schemas.openxmlformats.org/officeDocument/2006/relationships" id="267" r:id="R7bf5450d1bbe48bb"/>
   </p:sldIdLst>
   <p:sldSz cx="12192000" cy="6858000"/>
   <p:notesSz cx="6858000" cy="9144000"/>
@@ -1411,7 +1411,7 @@
   </p:cSld>
   <p:clrMap bg1="lt1" tx1="dk1" bg2="lt2" tx2="dk2" accent1="accent1" accent2="accent2" accent3="accent3" accent4="accent4" accent5="accent5" accent6="accent6" hlink="hlink" folHlink="folHlink"/>
   <p:sldLayoutIdLst>
-    <p:sldLayoutId xmlns:r="http://schemas.openxmlformats.org/officeDocument/2006/relationships" id="2147483649" r:id="Re554b1b1054a4da9"/>
+    <p:sldLayoutId xmlns:r="http://schemas.openxmlformats.org/officeDocument/2006/relationships" id="2147483649" r:id="R309ab86d57004ff5"/>
   </p:sldLayoutIdLst>
   <p:txStyles>
     <p:titleStyle>
@@ -1962,7 +1962,7 @@
           <p:cNvPr id="6" name="">
             <a:extLst xmlns:a="http://schemas.openxmlformats.org/drawingml/2006/main">
               <a:ext uri="{FF2B5EF4-FFF2-40B4-BE49-F238E27FC236}">
-                <a16:creationId xmlns:a16="http://schemas.microsoft.com/office/drawing/2014/main" id="{DE39C15F-DB35-4C06-8C88-D0FF1626FB50}"/>
+                <a16:creationId xmlns:a16="http://schemas.microsoft.com/office/drawing/2014/main" id="{295BE32A-0E1F-40A4-9F0A-4A23734ADACB}"/>
               </a:ext>
             </a:extLst>
           </p:cNvPr>
@@ -2042,7 +2042,7 @@
           <p:cNvPr id="2" name="">
             <a:extLst xmlns:a="http://schemas.openxmlformats.org/drawingml/2006/main">
               <a:ext uri="{FF2B5EF4-FFF2-40B4-BE49-F238E27FC236}">
-                <a16:creationId xmlns:a16="http://schemas.microsoft.com/office/drawing/2014/main" id="{5854A727-8A16-47CF-B073-A7A1179AB540}"/>
+                <a16:creationId xmlns:a16="http://schemas.microsoft.com/office/drawing/2014/main" id="{0E8D552B-8852-4DD6-A1B8-0A279B439C66}"/>
               </a:ext>
             </a:extLst>
           </p:cNvPr>
@@ -2122,7 +2122,7 @@
           <p:cNvPr id="3" name="">
             <a:extLst xmlns:a="http://schemas.openxmlformats.org/drawingml/2006/main">
               <a:ext uri="{FF2B5EF4-FFF2-40B4-BE49-F238E27FC236}">
-                <a16:creationId xmlns:a16="http://schemas.microsoft.com/office/drawing/2014/main" id="{DD2F83E0-9983-49D6-B17D-947EF539EBCB}"/>
+                <a16:creationId xmlns:a16="http://schemas.microsoft.com/office/drawing/2014/main" id="{FB44FC1D-205B-4C1A-9DB9-D3A5CE035965}"/>
               </a:ext>
             </a:extLst>
           </p:cNvPr>
@@ -2183,7 +2183,7 @@
           <p:nvPr/>
         </p:nvPicPr>
         <p:blipFill>
-          <a:blip xmlns:r="http://schemas.openxmlformats.org/officeDocument/2006/relationships" xmlns:a="http://schemas.openxmlformats.org/drawingml/2006/main" r:embed="R155c0b40960d4bab"/>
+          <a:blip xmlns:r="http://schemas.openxmlformats.org/officeDocument/2006/relationships" xmlns:a="http://schemas.openxmlformats.org/drawingml/2006/main" r:embed="R234299f22ff149ac"/>
           <a:stretch xmlns:a="http://schemas.openxmlformats.org/drawingml/2006/main"/>
         </p:blipFill>
         <p:spPr>
@@ -2201,7 +2201,7 @@
           <p:cNvPr id="5" name="">
             <a:extLst xmlns:a="http://schemas.openxmlformats.org/drawingml/2006/main">
               <a:ext uri="{FF2B5EF4-FFF2-40B4-BE49-F238E27FC236}">
-                <a16:creationId xmlns:a16="http://schemas.microsoft.com/office/drawing/2014/main" id="{89646594-B8C9-41FF-B2C5-DF06B581D319}"/>
+                <a16:creationId xmlns:a16="http://schemas.microsoft.com/office/drawing/2014/main" id="{089E483A-9970-4565-BFBA-F8303D31A120}"/>
               </a:ext>
             </a:extLst>
           </p:cNvPr>
@@ -2256,7 +2256,7 @@
     </p:spTree>
     <p:extLst>
       <p:ext uri="{BB962C8B-B14F-4D97-AF65-F5344CB8AC3E}">
-        <p14:creationId xmlns:p14="http://schemas.microsoft.com/office/powerpoint/2010/main" val="2110396613"/>
+        <p14:creationId xmlns:p14="http://schemas.microsoft.com/office/powerpoint/2010/main" val="1336309995"/>
       </p:ext>
     </p:extLst>
   </p:cSld>
@@ -2287,7 +2287,7 @@
           <p:cNvPr id="7" name="">
             <a:extLst xmlns:a="http://schemas.openxmlformats.org/drawingml/2006/main">
               <a:ext uri="{FF2B5EF4-FFF2-40B4-BE49-F238E27FC236}">
-                <a16:creationId xmlns:a16="http://schemas.microsoft.com/office/drawing/2014/main" id="{2F26DABF-D09D-456A-B8E5-E69B127574B5}"/>
+                <a16:creationId xmlns:a16="http://schemas.microsoft.com/office/drawing/2014/main" id="{1A089883-FFB6-44DB-9D59-67BC3D07340F}"/>
               </a:ext>
             </a:extLst>
           </p:cNvPr>
@@ -2367,7 +2367,7 @@
           <p:cNvPr id="2" name="">
             <a:extLst xmlns:a="http://schemas.openxmlformats.org/drawingml/2006/main">
               <a:ext uri="{FF2B5EF4-FFF2-40B4-BE49-F238E27FC236}">
-                <a16:creationId xmlns:a16="http://schemas.microsoft.com/office/drawing/2014/main" id="{4654FE7F-D361-4B2D-8DCB-EE974589DF4D}"/>
+                <a16:creationId xmlns:a16="http://schemas.microsoft.com/office/drawing/2014/main" id="{5ECFB689-7189-4560-83F4-419517EBBF4A}"/>
               </a:ext>
             </a:extLst>
           </p:cNvPr>
@@ -2424,7 +2424,7 @@
           <p:cNvPr id="3" name="">
             <a:extLst xmlns:a="http://schemas.openxmlformats.org/drawingml/2006/main">
               <a:ext uri="{FF2B5EF4-FFF2-40B4-BE49-F238E27FC236}">
-                <a16:creationId xmlns:a16="http://schemas.microsoft.com/office/drawing/2014/main" id="{8A0D4037-D0A2-43EA-A2E1-C58BFBF241FC}"/>
+                <a16:creationId xmlns:a16="http://schemas.microsoft.com/office/drawing/2014/main" id="{53AC1545-C46C-4BD7-A575-A06BCE4865D3}"/>
               </a:ext>
             </a:extLst>
           </p:cNvPr>
@@ -2481,7 +2481,7 @@
           <p:cNvPr id="4" name="">
             <a:extLst xmlns:a="http://schemas.openxmlformats.org/drawingml/2006/main">
               <a:ext uri="{FF2B5EF4-FFF2-40B4-BE49-F238E27FC236}">
-                <a16:creationId xmlns:a16="http://schemas.microsoft.com/office/drawing/2014/main" id="{A9091631-E77C-4B4A-B445-89129B08D4FE}"/>
+                <a16:creationId xmlns:a16="http://schemas.microsoft.com/office/drawing/2014/main" id="{B11E55B0-BB03-4796-903A-BC6BBD699683}"/>
               </a:ext>
             </a:extLst>
           </p:cNvPr>
@@ -2588,7 +2588,7 @@
           <p:nvPr/>
         </p:nvPicPr>
         <p:blipFill>
-          <a:blip xmlns:r="http://schemas.openxmlformats.org/officeDocument/2006/relationships" xmlns:a="http://schemas.openxmlformats.org/drawingml/2006/main" r:embed="R47ac423e21c64950"/>
+          <a:blip xmlns:r="http://schemas.openxmlformats.org/officeDocument/2006/relationships" xmlns:a="http://schemas.openxmlformats.org/drawingml/2006/main" r:embed="R887a8efaddca4dce"/>
           <a:stretch xmlns:a="http://schemas.openxmlformats.org/drawingml/2006/main"/>
         </p:blipFill>
         <p:spPr>
@@ -2606,7 +2606,7 @@
           <p:cNvPr id="6" name="">
             <a:extLst xmlns:a="http://schemas.openxmlformats.org/drawingml/2006/main">
               <a:ext uri="{FF2B5EF4-FFF2-40B4-BE49-F238E27FC236}">
-                <a16:creationId xmlns:a16="http://schemas.microsoft.com/office/drawing/2014/main" id="{8AF6FCC2-1292-4135-BB05-F7E7FDB164FF}"/>
+                <a16:creationId xmlns:a16="http://schemas.microsoft.com/office/drawing/2014/main" id="{FC806478-E234-4980-A1EB-773D3983C1E7}"/>
               </a:ext>
             </a:extLst>
           </p:cNvPr>
@@ -2661,7 +2661,7 @@
     </p:spTree>
     <p:extLst>
       <p:ext uri="{BB962C8B-B14F-4D97-AF65-F5344CB8AC3E}">
-        <p14:creationId xmlns:p14="http://schemas.microsoft.com/office/powerpoint/2010/main" val="1512686366"/>
+        <p14:creationId xmlns:p14="http://schemas.microsoft.com/office/powerpoint/2010/main" val="371510501"/>
       </p:ext>
     </p:extLst>
   </p:cSld>
@@ -2692,7 +2692,7 @@
           <p:cNvPr id="5" name="">
             <a:extLst xmlns:a="http://schemas.openxmlformats.org/drawingml/2006/main">
               <a:ext uri="{FF2B5EF4-FFF2-40B4-BE49-F238E27FC236}">
-                <a16:creationId xmlns:a16="http://schemas.microsoft.com/office/drawing/2014/main" id="{7731960D-C6D3-432D-95DD-F46873DF213A}"/>
+                <a16:creationId xmlns:a16="http://schemas.microsoft.com/office/drawing/2014/main" id="{03185648-8144-4277-941D-1ACB95ADCB00}"/>
               </a:ext>
             </a:extLst>
           </p:cNvPr>
@@ -2772,7 +2772,7 @@
           <p:cNvPr id="2" name="">
             <a:extLst xmlns:a="http://schemas.openxmlformats.org/drawingml/2006/main">
               <a:ext uri="{FF2B5EF4-FFF2-40B4-BE49-F238E27FC236}">
-                <a16:creationId xmlns:a16="http://schemas.microsoft.com/office/drawing/2014/main" id="{4AB8A3C6-E29E-4069-B820-DF5ACC3B56BF}"/>
+                <a16:creationId xmlns:a16="http://schemas.microsoft.com/office/drawing/2014/main" id="{F4C17E07-DE48-4290-980D-32C1C67D2E5F}"/>
               </a:ext>
             </a:extLst>
           </p:cNvPr>
@@ -2829,7 +2829,7 @@
           <p:cNvPr id="3" name="">
             <a:extLst xmlns:a="http://schemas.openxmlformats.org/drawingml/2006/main">
               <a:ext uri="{FF2B5EF4-FFF2-40B4-BE49-F238E27FC236}">
-                <a16:creationId xmlns:a16="http://schemas.microsoft.com/office/drawing/2014/main" id="{AAFA8126-72B5-4BCD-BF47-75746FA4E811}"/>
+                <a16:creationId xmlns:a16="http://schemas.microsoft.com/office/drawing/2014/main" id="{6D3EA1BD-42C8-4ED4-9530-1BA530C7DE82}"/>
               </a:ext>
             </a:extLst>
           </p:cNvPr>
@@ -2909,7 +2909,7 @@
           <p:cNvPr id="4" name="">
             <a:extLst xmlns:a="http://schemas.openxmlformats.org/drawingml/2006/main">
               <a:ext uri="{FF2B5EF4-FFF2-40B4-BE49-F238E27FC236}">
-                <a16:creationId xmlns:a16="http://schemas.microsoft.com/office/drawing/2014/main" id="{47D50D6F-D29D-4206-B1A9-B40CDE8C3F7C}"/>
+                <a16:creationId xmlns:a16="http://schemas.microsoft.com/office/drawing/2014/main" id="{C8E3236E-73F1-4D85-B324-F87023562432}"/>
               </a:ext>
             </a:extLst>
           </p:cNvPr>
@@ -2987,7 +2987,7 @@
     </p:spTree>
     <p:extLst>
       <p:ext uri="{BB962C8B-B14F-4D97-AF65-F5344CB8AC3E}">
-        <p14:creationId xmlns:p14="http://schemas.microsoft.com/office/powerpoint/2010/main" val="518591479"/>
+        <p14:creationId xmlns:p14="http://schemas.microsoft.com/office/powerpoint/2010/main" val="866894837"/>
       </p:ext>
     </p:extLst>
   </p:cSld>
@@ -3015,10 +3015,10 @@
       </p:grpSpPr>
       <p:sp>
         <p:nvSpPr>
-          <p:cNvPr id="5" name="">
+          <p:cNvPr id="7" name="">
             <a:extLst xmlns:a="http://schemas.openxmlformats.org/drawingml/2006/main">
               <a:ext uri="{FF2B5EF4-FFF2-40B4-BE49-F238E27FC236}">
-                <a16:creationId xmlns:a16="http://schemas.microsoft.com/office/drawing/2014/main" id="{44F53213-7A5A-49CC-BF03-13D04A4943C5}"/>
+                <a16:creationId xmlns:a16="http://schemas.microsoft.com/office/drawing/2014/main" id="{BE75F7D8-1937-4CA3-8B2F-BBE92398FC38}"/>
               </a:ext>
             </a:extLst>
           </p:cNvPr>
@@ -3098,7 +3098,7 @@
           <p:cNvPr id="2" name="">
             <a:extLst xmlns:a="http://schemas.openxmlformats.org/drawingml/2006/main">
               <a:ext uri="{FF2B5EF4-FFF2-40B4-BE49-F238E27FC236}">
-                <a16:creationId xmlns:a16="http://schemas.microsoft.com/office/drawing/2014/main" id="{3611AF2B-E807-40B4-87EB-1BA902A126E6}"/>
+                <a16:creationId xmlns:a16="http://schemas.microsoft.com/office/drawing/2014/main" id="{9DB0B721-2F14-416D-864D-CD0B6A220E4D}"/>
               </a:ext>
             </a:extLst>
           </p:cNvPr>
@@ -3178,7 +3178,7 @@
           <p:cNvPr id="3" name="">
             <a:extLst xmlns:a="http://schemas.openxmlformats.org/drawingml/2006/main">
               <a:ext uri="{FF2B5EF4-FFF2-40B4-BE49-F238E27FC236}">
-                <a16:creationId xmlns:a16="http://schemas.microsoft.com/office/drawing/2014/main" id="{A028444A-5DCF-4CD8-99FE-77E62A205273}"/>
+                <a16:creationId xmlns:a16="http://schemas.microsoft.com/office/drawing/2014/main" id="{DA5317BA-E8D9-44E3-9C35-CB8D0646011E}"/>
               </a:ext>
             </a:extLst>
           </p:cNvPr>
@@ -3258,7 +3258,7 @@
           <p:cNvPr id="4" name="">
             <a:extLst xmlns:a="http://schemas.openxmlformats.org/drawingml/2006/main">
               <a:ext uri="{FF2B5EF4-FFF2-40B4-BE49-F238E27FC236}">
-                <a16:creationId xmlns:a16="http://schemas.microsoft.com/office/drawing/2014/main" id="{964EB649-7783-4B42-B136-52C345C8A213}"/>
+                <a16:creationId xmlns:a16="http://schemas.microsoft.com/office/drawing/2014/main" id="{E14B3D7C-D8C5-4558-9B5A-8E87B972932B}"/>
               </a:ext>
             </a:extLst>
           </p:cNvPr>
@@ -3269,8 +3269,8 @@
         </p:nvSpPr>
         <p:spPr>
           <a:xfrm xmlns:a="http://schemas.openxmlformats.org/drawingml/2006/main">
-            <a:off x="771525" y="6238875"/>
-            <a:ext cx="10668000" cy="419100"/>
+            <a:off x="771525" y="5753100"/>
+            <a:ext cx="10668000" cy="304800"/>
           </a:xfrm>
           <a:prstGeom xmlns:a="http://schemas.openxmlformats.org/drawingml/2006/main" prst="rect">
             <a:avLst/>
@@ -3287,7 +3287,7 @@
           <a:lstStyle xmlns:a="http://schemas.openxmlformats.org/drawingml/2006/main"/>
           <a:p xmlns:a="http://schemas.openxmlformats.org/drawingml/2006/main">
             <a:pPr>
-              <a:defRPr sz="1875" b="0">
+              <a:defRPr sz="1500" b="0">
                 <a:solidFill>
                   <a:srgbClr val="B0C4D4"/>
                 </a:solidFill>
@@ -3297,7 +3297,7 @@
               </a:defRPr>
             </a:pPr>
             <a:r>
-              <a:rPr sz="1875" b="0">
+              <a:rPr sz="1500" b="0">
                 <a:solidFill>
                   <a:srgbClr val="B0C4D4"/>
                 </a:solidFill>
@@ -3306,6 +3306,120 @@
                 <a:cs typeface="Helvetica Neue"/>
               </a:rPr>
               <a:t>Concept by Rafael. An aid to buddy procedures, never a safety guarantee.</a:t>
+            </a:r>
+          </a:p>
+        </p:txBody>
+      </p:sp>
+      <p:sp>
+        <p:nvSpPr>
+          <p:cNvPr id="5" name="">
+            <a:extLst xmlns:a="http://schemas.openxmlformats.org/drawingml/2006/main">
+              <a:ext uri="{FF2B5EF4-FFF2-40B4-BE49-F238E27FC236}">
+                <a16:creationId xmlns:a16="http://schemas.microsoft.com/office/drawing/2014/main" id="{8B2BFDEA-D08A-4261-8185-CFB65BDA8838}"/>
+              </a:ext>
+            </a:extLst>
+          </p:cNvPr>
+          <p:cNvSpPr>
+            <a:spLocks xmlns:a="http://schemas.openxmlformats.org/drawingml/2006/main" noGrp="1"/>
+          </p:cNvSpPr>
+          <p:nvPr/>
+        </p:nvSpPr>
+        <p:spPr>
+          <a:xfrm xmlns:a="http://schemas.openxmlformats.org/drawingml/2006/main">
+            <a:off x="771525" y="6172200"/>
+            <a:ext cx="10668000" cy="295275"/>
+          </a:xfrm>
+          <a:prstGeom xmlns:a="http://schemas.openxmlformats.org/drawingml/2006/main" prst="rect">
+            <a:avLst/>
+          </a:prstGeom>
+          <a:noFill xmlns:a="http://schemas.openxmlformats.org/drawingml/2006/main"/>
+          <a:ln xmlns:a="http://schemas.openxmlformats.org/drawingml/2006/main" w="0">
+            <a:noFill/>
+          </a:ln>
+        </p:spPr>
+        <p:txBody>
+          <a:bodyPr xmlns:a="http://schemas.openxmlformats.org/drawingml/2006/main">
+            <a:noAutofit/>
+          </a:bodyPr>
+          <a:lstStyle xmlns:a="http://schemas.openxmlformats.org/drawingml/2006/main"/>
+          <a:p xmlns:a="http://schemas.openxmlformats.org/drawingml/2006/main">
+            <a:pPr>
+              <a:defRPr sz="1650" b="0">
+                <a:solidFill>
+                  <a:srgbClr val="F0F4F7"/>
+                </a:solidFill>
+                <a:latin typeface="Helvetica Neue"/>
+                <a:ea typeface="Helvetica Neue"/>
+                <a:cs typeface="Helvetica Neue"/>
+              </a:defRPr>
+            </a:pPr>
+            <a:r>
+              <a:rPr sz="1650" b="0">
+                <a:solidFill>
+                  <a:srgbClr val="F0F4F7"/>
+                </a:solidFill>
+                <a:latin typeface="Helvetica Neue"/>
+                <a:ea typeface="Helvetica Neue"/>
+                <a:cs typeface="Helvetica Neue"/>
+              </a:rPr>
+              <a:t>Presentation strategy, design &amp; production by The AI Doc</a:t>
+            </a:r>
+          </a:p>
+        </p:txBody>
+      </p:sp>
+      <p:sp>
+        <p:nvSpPr>
+          <p:cNvPr id="6" name="">
+            <a:extLst xmlns:a="http://schemas.openxmlformats.org/drawingml/2006/main">
+              <a:ext uri="{FF2B5EF4-FFF2-40B4-BE49-F238E27FC236}">
+                <a16:creationId xmlns:a16="http://schemas.microsoft.com/office/drawing/2014/main" id="{B2C63B6E-9F4B-467B-AF3B-F522A75BD47C}"/>
+              </a:ext>
+            </a:extLst>
+          </p:cNvPr>
+          <p:cNvSpPr>
+            <a:spLocks xmlns:a="http://schemas.openxmlformats.org/drawingml/2006/main" noGrp="1"/>
+          </p:cNvSpPr>
+          <p:nvPr/>
+        </p:nvSpPr>
+        <p:spPr>
+          <a:xfrm xmlns:a="http://schemas.openxmlformats.org/drawingml/2006/main">
+            <a:off x="771525" y="6515100"/>
+            <a:ext cx="10668000" cy="257175"/>
+          </a:xfrm>
+          <a:prstGeom xmlns:a="http://schemas.openxmlformats.org/drawingml/2006/main" prst="rect">
+            <a:avLst/>
+          </a:prstGeom>
+          <a:noFill xmlns:a="http://schemas.openxmlformats.org/drawingml/2006/main"/>
+          <a:ln xmlns:a="http://schemas.openxmlformats.org/drawingml/2006/main" w="0">
+            <a:noFill/>
+          </a:ln>
+        </p:spPr>
+        <p:txBody>
+          <a:bodyPr xmlns:a="http://schemas.openxmlformats.org/drawingml/2006/main">
+            <a:noAutofit/>
+          </a:bodyPr>
+          <a:lstStyle xmlns:a="http://schemas.openxmlformats.org/drawingml/2006/main"/>
+          <a:p xmlns:a="http://schemas.openxmlformats.org/drawingml/2006/main">
+            <a:pPr>
+              <a:defRPr sz="1350" b="0">
+                <a:solidFill>
+                  <a:srgbClr val="B0C4D4"/>
+                </a:solidFill>
+                <a:latin typeface="Helvetica Neue"/>
+                <a:ea typeface="Helvetica Neue"/>
+                <a:cs typeface="Helvetica Neue"/>
+              </a:defRPr>
+            </a:pPr>
+            <a:r>
+              <a:rPr sz="1350" b="0">
+                <a:solidFill>
+                  <a:srgbClr val="B0C4D4"/>
+                </a:solidFill>
+                <a:latin typeface="Helvetica Neue"/>
+                <a:ea typeface="Helvetica Neue"/>
+                <a:cs typeface="Helvetica Neue"/>
+              </a:rPr>
+              <a:t>Prepared for Rafael</a:t>
             </a:r>
           </a:p>
         </p:txBody>
@@ -3313,7 +3427,7 @@
     </p:spTree>
     <p:extLst>
       <p:ext uri="{BB962C8B-B14F-4D97-AF65-F5344CB8AC3E}">
-        <p14:creationId xmlns:p14="http://schemas.microsoft.com/office/powerpoint/2010/main" val="1660671051"/>
+        <p14:creationId xmlns:p14="http://schemas.microsoft.com/office/powerpoint/2010/main" val="111407430"/>
       </p:ext>
     </p:extLst>
   </p:cSld>
@@ -3344,7 +3458,7 @@
           <p:cNvPr id="5" name="">
             <a:extLst xmlns:a="http://schemas.openxmlformats.org/drawingml/2006/main">
               <a:ext uri="{FF2B5EF4-FFF2-40B4-BE49-F238E27FC236}">
-                <a16:creationId xmlns:a16="http://schemas.microsoft.com/office/drawing/2014/main" id="{23E2493A-4233-44F0-B027-1FA4A1A16EBE}"/>
+                <a16:creationId xmlns:a16="http://schemas.microsoft.com/office/drawing/2014/main" id="{77CCCC33-5427-43AC-9B25-4E962092A56F}"/>
               </a:ext>
             </a:extLst>
           </p:cNvPr>
@@ -3424,7 +3538,7 @@
           <p:cNvPr id="2" name="">
             <a:extLst xmlns:a="http://schemas.openxmlformats.org/drawingml/2006/main">
               <a:ext uri="{FF2B5EF4-FFF2-40B4-BE49-F238E27FC236}">
-                <a16:creationId xmlns:a16="http://schemas.microsoft.com/office/drawing/2014/main" id="{8423B221-E513-4122-A573-4C104D01BACB}"/>
+                <a16:creationId xmlns:a16="http://schemas.microsoft.com/office/drawing/2014/main" id="{2DF4D6B4-3D82-42CE-8556-106DF32540C4}"/>
               </a:ext>
             </a:extLst>
           </p:cNvPr>
@@ -3504,7 +3618,7 @@
           <p:cNvPr id="3" name="">
             <a:extLst xmlns:a="http://schemas.openxmlformats.org/drawingml/2006/main">
               <a:ext uri="{FF2B5EF4-FFF2-40B4-BE49-F238E27FC236}">
-                <a16:creationId xmlns:a16="http://schemas.microsoft.com/office/drawing/2014/main" id="{1007131E-26A6-401B-A897-E2B97ED5FEF8}"/>
+                <a16:creationId xmlns:a16="http://schemas.microsoft.com/office/drawing/2014/main" id="{3C42938B-2A56-4F0A-88CB-C2DB6B24489A}"/>
               </a:ext>
             </a:extLst>
           </p:cNvPr>
@@ -3584,7 +3698,7 @@
           <p:cNvPr id="4" name="">
             <a:extLst xmlns:a="http://schemas.openxmlformats.org/drawingml/2006/main">
               <a:ext uri="{FF2B5EF4-FFF2-40B4-BE49-F238E27FC236}">
-                <a16:creationId xmlns:a16="http://schemas.microsoft.com/office/drawing/2014/main" id="{1C110B8B-C6BC-42A6-8E89-54F94C2A9881}"/>
+                <a16:creationId xmlns:a16="http://schemas.microsoft.com/office/drawing/2014/main" id="{3B8754B8-21CF-474B-9E23-90EE56912FD7}"/>
               </a:ext>
             </a:extLst>
           </p:cNvPr>
@@ -3639,7 +3753,7 @@
     </p:spTree>
     <p:extLst>
       <p:ext uri="{BB962C8B-B14F-4D97-AF65-F5344CB8AC3E}">
-        <p14:creationId xmlns:p14="http://schemas.microsoft.com/office/powerpoint/2010/main" val="613121401"/>
+        <p14:creationId xmlns:p14="http://schemas.microsoft.com/office/powerpoint/2010/main" val="1641380213"/>
       </p:ext>
     </p:extLst>
   </p:cSld>
@@ -3670,7 +3784,7 @@
           <p:cNvPr id="7" name="">
             <a:extLst xmlns:a="http://schemas.openxmlformats.org/drawingml/2006/main">
               <a:ext uri="{FF2B5EF4-FFF2-40B4-BE49-F238E27FC236}">
-                <a16:creationId xmlns:a16="http://schemas.microsoft.com/office/drawing/2014/main" id="{A2327635-CB82-4B11-8580-2815A903A21F}"/>
+                <a16:creationId xmlns:a16="http://schemas.microsoft.com/office/drawing/2014/main" id="{0C70E876-49BD-4C6D-9467-D970EF881E64}"/>
               </a:ext>
             </a:extLst>
           </p:cNvPr>
@@ -3750,7 +3864,7 @@
           <p:cNvPr id="2" name="">
             <a:extLst xmlns:a="http://schemas.openxmlformats.org/drawingml/2006/main">
               <a:ext uri="{FF2B5EF4-FFF2-40B4-BE49-F238E27FC236}">
-                <a16:creationId xmlns:a16="http://schemas.microsoft.com/office/drawing/2014/main" id="{DA0F1436-192F-46E4-AF11-7C0101F4B786}"/>
+                <a16:creationId xmlns:a16="http://schemas.microsoft.com/office/drawing/2014/main" id="{12D78DD4-55E0-4BC7-B32F-01534208FDE5}"/>
               </a:ext>
             </a:extLst>
           </p:cNvPr>
@@ -3807,7 +3921,7 @@
           <p:cNvPr id="3" name="">
             <a:extLst xmlns:a="http://schemas.openxmlformats.org/drawingml/2006/main">
               <a:ext uri="{FF2B5EF4-FFF2-40B4-BE49-F238E27FC236}">
-                <a16:creationId xmlns:a16="http://schemas.microsoft.com/office/drawing/2014/main" id="{4E2E106C-721E-401A-8A3D-487E4D33F13C}"/>
+                <a16:creationId xmlns:a16="http://schemas.microsoft.com/office/drawing/2014/main" id="{2A66BAAE-26C5-4135-9F85-2C421ECC2C6D}"/>
               </a:ext>
             </a:extLst>
           </p:cNvPr>
@@ -3910,7 +4024,7 @@
           <p:cNvPr id="4" name="">
             <a:extLst xmlns:a="http://schemas.openxmlformats.org/drawingml/2006/main">
               <a:ext uri="{FF2B5EF4-FFF2-40B4-BE49-F238E27FC236}">
-                <a16:creationId xmlns:a16="http://schemas.microsoft.com/office/drawing/2014/main" id="{3DB08337-A5CB-4EC0-A36A-9713BE85B66C}"/>
+                <a16:creationId xmlns:a16="http://schemas.microsoft.com/office/drawing/2014/main" id="{C78B8AF1-1C0A-4E6F-BF62-36DD6BED84BA}"/>
               </a:ext>
             </a:extLst>
           </p:cNvPr>
@@ -3967,7 +4081,7 @@
           <p:cNvPr id="5" name="">
             <a:extLst xmlns:a="http://schemas.openxmlformats.org/drawingml/2006/main">
               <a:ext uri="{FF2B5EF4-FFF2-40B4-BE49-F238E27FC236}">
-                <a16:creationId xmlns:a16="http://schemas.microsoft.com/office/drawing/2014/main" id="{33CBAA3A-6096-447C-94AC-6D31972E4A50}"/>
+                <a16:creationId xmlns:a16="http://schemas.microsoft.com/office/drawing/2014/main" id="{E0367549-CA97-4819-92D5-E0D9C13FFADB}"/>
               </a:ext>
             </a:extLst>
           </p:cNvPr>
@@ -4070,7 +4184,7 @@
           <p:cNvPr id="6" name="">
             <a:extLst xmlns:a="http://schemas.openxmlformats.org/drawingml/2006/main">
               <a:ext uri="{FF2B5EF4-FFF2-40B4-BE49-F238E27FC236}">
-                <a16:creationId xmlns:a16="http://schemas.microsoft.com/office/drawing/2014/main" id="{6C92655C-93B1-40B8-A5A0-B9B891C8476D}"/>
+                <a16:creationId xmlns:a16="http://schemas.microsoft.com/office/drawing/2014/main" id="{1499B3B9-33CE-4EAD-93B3-131B0FFFE478}"/>
               </a:ext>
             </a:extLst>
           </p:cNvPr>
@@ -4125,7 +4239,7 @@
     </p:spTree>
     <p:extLst>
       <p:ext uri="{BB962C8B-B14F-4D97-AF65-F5344CB8AC3E}">
-        <p14:creationId xmlns:p14="http://schemas.microsoft.com/office/powerpoint/2010/main" val="140495266"/>
+        <p14:creationId xmlns:p14="http://schemas.microsoft.com/office/powerpoint/2010/main" val="1317804993"/>
       </p:ext>
     </p:extLst>
   </p:cSld>
@@ -4156,7 +4270,7 @@
           <p:cNvPr id="19" name="">
             <a:extLst xmlns:a="http://schemas.openxmlformats.org/drawingml/2006/main">
               <a:ext uri="{FF2B5EF4-FFF2-40B4-BE49-F238E27FC236}">
-                <a16:creationId xmlns:a16="http://schemas.microsoft.com/office/drawing/2014/main" id="{5BDDF5BF-AB7C-4FB4-B520-7B69D95DD4E4}"/>
+                <a16:creationId xmlns:a16="http://schemas.microsoft.com/office/drawing/2014/main" id="{1AF80D6F-6CB3-46F8-A77C-C74E90D9348A}"/>
               </a:ext>
             </a:extLst>
           </p:cNvPr>
@@ -4236,7 +4350,7 @@
           <p:cNvPr id="2" name="">
             <a:extLst xmlns:a="http://schemas.openxmlformats.org/drawingml/2006/main">
               <a:ext uri="{FF2B5EF4-FFF2-40B4-BE49-F238E27FC236}">
-                <a16:creationId xmlns:a16="http://schemas.microsoft.com/office/drawing/2014/main" id="{8EE2B2F6-4810-44BC-A522-56FDE36B91F6}"/>
+                <a16:creationId xmlns:a16="http://schemas.microsoft.com/office/drawing/2014/main" id="{DED7950A-54A5-4103-ADC5-C0BF0323A1F6}"/>
               </a:ext>
             </a:extLst>
           </p:cNvPr>
@@ -4268,7 +4382,7 @@
           <p:cNvPr id="3" name="">
             <a:extLst xmlns:a="http://schemas.openxmlformats.org/drawingml/2006/main">
               <a:ext uri="{FF2B5EF4-FFF2-40B4-BE49-F238E27FC236}">
-                <a16:creationId xmlns:a16="http://schemas.microsoft.com/office/drawing/2014/main" id="{761B28EC-31C8-4216-92AF-FE281F567E02}"/>
+                <a16:creationId xmlns:a16="http://schemas.microsoft.com/office/drawing/2014/main" id="{8EEA662F-B803-411D-8379-69C7B64A759F}"/>
               </a:ext>
             </a:extLst>
           </p:cNvPr>
@@ -4325,7 +4439,7 @@
           <p:cNvPr id="4" name="">
             <a:extLst xmlns:a="http://schemas.openxmlformats.org/drawingml/2006/main">
               <a:ext uri="{FF2B5EF4-FFF2-40B4-BE49-F238E27FC236}">
-                <a16:creationId xmlns:a16="http://schemas.microsoft.com/office/drawing/2014/main" id="{FD6DE3C6-4C58-4F00-AC80-72BCA4CF4E57}"/>
+                <a16:creationId xmlns:a16="http://schemas.microsoft.com/office/drawing/2014/main" id="{39D7CCDC-AEB3-4013-97EB-A86F44CA3966}"/>
               </a:ext>
             </a:extLst>
           </p:cNvPr>
@@ -4382,7 +4496,7 @@
           <p:cNvPr id="5" name="">
             <a:extLst xmlns:a="http://schemas.openxmlformats.org/drawingml/2006/main">
               <a:ext uri="{FF2B5EF4-FFF2-40B4-BE49-F238E27FC236}">
-                <a16:creationId xmlns:a16="http://schemas.microsoft.com/office/drawing/2014/main" id="{759CE0D3-24D6-4C74-A362-3C50B74F0637}"/>
+                <a16:creationId xmlns:a16="http://schemas.microsoft.com/office/drawing/2014/main" id="{3A45038C-6112-4EE3-932F-00F2A1074921}"/>
               </a:ext>
             </a:extLst>
           </p:cNvPr>
@@ -4439,7 +4553,7 @@
           <p:cNvPr id="6" name="">
             <a:extLst xmlns:a="http://schemas.openxmlformats.org/drawingml/2006/main">
               <a:ext uri="{FF2B5EF4-FFF2-40B4-BE49-F238E27FC236}">
-                <a16:creationId xmlns:a16="http://schemas.microsoft.com/office/drawing/2014/main" id="{499A9B5A-739F-440D-8EFA-7014EA45A8BF}"/>
+                <a16:creationId xmlns:a16="http://schemas.microsoft.com/office/drawing/2014/main" id="{2F2D16EB-1F10-41E5-A8F2-B91E15D4F558}"/>
               </a:ext>
             </a:extLst>
           </p:cNvPr>
@@ -4496,7 +4610,7 @@
           <p:cNvPr id="7" name="">
             <a:extLst xmlns:a="http://schemas.openxmlformats.org/drawingml/2006/main">
               <a:ext uri="{FF2B5EF4-FFF2-40B4-BE49-F238E27FC236}">
-                <a16:creationId xmlns:a16="http://schemas.microsoft.com/office/drawing/2014/main" id="{2A9C2BF7-34DB-47A1-85E5-F52CB1D7F33F}"/>
+                <a16:creationId xmlns:a16="http://schemas.microsoft.com/office/drawing/2014/main" id="{A27FE2B6-81D5-436C-BE95-9FAA6FFAF179}"/>
               </a:ext>
             </a:extLst>
           </p:cNvPr>
@@ -4528,7 +4642,7 @@
           <p:cNvPr id="8" name="">
             <a:extLst xmlns:a="http://schemas.openxmlformats.org/drawingml/2006/main">
               <a:ext uri="{FF2B5EF4-FFF2-40B4-BE49-F238E27FC236}">
-                <a16:creationId xmlns:a16="http://schemas.microsoft.com/office/drawing/2014/main" id="{C6E3497D-7E65-4CFF-A17C-E9E96D6E2FBE}"/>
+                <a16:creationId xmlns:a16="http://schemas.microsoft.com/office/drawing/2014/main" id="{D352BFB2-5A75-4DC2-94E2-C4E58322F051}"/>
               </a:ext>
             </a:extLst>
           </p:cNvPr>
@@ -4585,7 +4699,7 @@
           <p:cNvPr id="9" name="">
             <a:extLst xmlns:a="http://schemas.openxmlformats.org/drawingml/2006/main">
               <a:ext uri="{FF2B5EF4-FFF2-40B4-BE49-F238E27FC236}">
-                <a16:creationId xmlns:a16="http://schemas.microsoft.com/office/drawing/2014/main" id="{ABC9F057-A5BD-4EAD-9126-7B8B17AA1552}"/>
+                <a16:creationId xmlns:a16="http://schemas.microsoft.com/office/drawing/2014/main" id="{FEA93D2B-29B2-45E2-98EB-32BCFBB4D948}"/>
               </a:ext>
             </a:extLst>
           </p:cNvPr>
@@ -4642,7 +4756,7 @@
           <p:cNvPr id="10" name="">
             <a:extLst xmlns:a="http://schemas.openxmlformats.org/drawingml/2006/main">
               <a:ext uri="{FF2B5EF4-FFF2-40B4-BE49-F238E27FC236}">
-                <a16:creationId xmlns:a16="http://schemas.microsoft.com/office/drawing/2014/main" id="{FF139E00-BF8F-4495-88D9-19842473975D}"/>
+                <a16:creationId xmlns:a16="http://schemas.microsoft.com/office/drawing/2014/main" id="{771B61D8-9ADA-4AD8-8254-E28E437B13CA}"/>
               </a:ext>
             </a:extLst>
           </p:cNvPr>
@@ -4699,7 +4813,7 @@
           <p:cNvPr id="11" name="">
             <a:extLst xmlns:a="http://schemas.openxmlformats.org/drawingml/2006/main">
               <a:ext uri="{FF2B5EF4-FFF2-40B4-BE49-F238E27FC236}">
-                <a16:creationId xmlns:a16="http://schemas.microsoft.com/office/drawing/2014/main" id="{F7ED504E-EEED-4F38-99B0-AC1D91D55AB3}"/>
+                <a16:creationId xmlns:a16="http://schemas.microsoft.com/office/drawing/2014/main" id="{1D72C252-9C0B-435B-946F-6AFFF35D8794}"/>
               </a:ext>
             </a:extLst>
           </p:cNvPr>
@@ -4756,7 +4870,7 @@
           <p:cNvPr id="12" name="">
             <a:extLst xmlns:a="http://schemas.openxmlformats.org/drawingml/2006/main">
               <a:ext uri="{FF2B5EF4-FFF2-40B4-BE49-F238E27FC236}">
-                <a16:creationId xmlns:a16="http://schemas.microsoft.com/office/drawing/2014/main" id="{A77EA953-C21C-4573-A7E6-E83BD3D9ECC0}"/>
+                <a16:creationId xmlns:a16="http://schemas.microsoft.com/office/drawing/2014/main" id="{E0EE51D3-50D7-49DA-999B-758205E8F53A}"/>
               </a:ext>
             </a:extLst>
           </p:cNvPr>
@@ -4788,7 +4902,7 @@
           <p:cNvPr id="13" name="">
             <a:extLst xmlns:a="http://schemas.openxmlformats.org/drawingml/2006/main">
               <a:ext uri="{FF2B5EF4-FFF2-40B4-BE49-F238E27FC236}">
-                <a16:creationId xmlns:a16="http://schemas.microsoft.com/office/drawing/2014/main" id="{02167035-F117-4D42-B986-26123AE243C1}"/>
+                <a16:creationId xmlns:a16="http://schemas.microsoft.com/office/drawing/2014/main" id="{A8C7768F-3D7A-47A5-9DA1-3B9B411FB6EE}"/>
               </a:ext>
             </a:extLst>
           </p:cNvPr>
@@ -4845,7 +4959,7 @@
           <p:cNvPr id="14" name="">
             <a:extLst xmlns:a="http://schemas.openxmlformats.org/drawingml/2006/main">
               <a:ext uri="{FF2B5EF4-FFF2-40B4-BE49-F238E27FC236}">
-                <a16:creationId xmlns:a16="http://schemas.microsoft.com/office/drawing/2014/main" id="{16557395-BA83-4104-8039-B1B2D2BA2F96}"/>
+                <a16:creationId xmlns:a16="http://schemas.microsoft.com/office/drawing/2014/main" id="{926EA1F3-3964-416A-B6AE-C6B81E62C9A5}"/>
               </a:ext>
             </a:extLst>
           </p:cNvPr>
@@ -4902,7 +5016,7 @@
           <p:cNvPr id="15" name="">
             <a:extLst xmlns:a="http://schemas.openxmlformats.org/drawingml/2006/main">
               <a:ext uri="{FF2B5EF4-FFF2-40B4-BE49-F238E27FC236}">
-                <a16:creationId xmlns:a16="http://schemas.microsoft.com/office/drawing/2014/main" id="{65A33D4F-B786-48B4-8485-9214F45484CA}"/>
+                <a16:creationId xmlns:a16="http://schemas.microsoft.com/office/drawing/2014/main" id="{D899E843-AD3B-4A99-99EC-4BC5427D4729}"/>
               </a:ext>
             </a:extLst>
           </p:cNvPr>
@@ -4959,7 +5073,7 @@
           <p:cNvPr id="16" name="">
             <a:extLst xmlns:a="http://schemas.openxmlformats.org/drawingml/2006/main">
               <a:ext uri="{FF2B5EF4-FFF2-40B4-BE49-F238E27FC236}">
-                <a16:creationId xmlns:a16="http://schemas.microsoft.com/office/drawing/2014/main" id="{745169EB-7662-463B-A038-3DB5A91DE7D2}"/>
+                <a16:creationId xmlns:a16="http://schemas.microsoft.com/office/drawing/2014/main" id="{FF95D2BF-DDF1-488D-8067-D79F13FCFD08}"/>
               </a:ext>
             </a:extLst>
           </p:cNvPr>
@@ -5016,7 +5130,7 @@
           <p:cNvPr id="17" name="">
             <a:extLst xmlns:a="http://schemas.openxmlformats.org/drawingml/2006/main">
               <a:ext uri="{FF2B5EF4-FFF2-40B4-BE49-F238E27FC236}">
-                <a16:creationId xmlns:a16="http://schemas.microsoft.com/office/drawing/2014/main" id="{6E664D66-3801-4CA0-ABDE-3C6A56B6632E}"/>
+                <a16:creationId xmlns:a16="http://schemas.microsoft.com/office/drawing/2014/main" id="{E7495408-A6B3-48B2-B469-FE2DDFCBFF19}"/>
               </a:ext>
             </a:extLst>
           </p:cNvPr>
@@ -5096,7 +5210,7 @@
           <p:cNvPr id="18" name="">
             <a:extLst xmlns:a="http://schemas.openxmlformats.org/drawingml/2006/main">
               <a:ext uri="{FF2B5EF4-FFF2-40B4-BE49-F238E27FC236}">
-                <a16:creationId xmlns:a16="http://schemas.microsoft.com/office/drawing/2014/main" id="{FD229A42-71F5-4974-AD1C-631D194C7180}"/>
+                <a16:creationId xmlns:a16="http://schemas.microsoft.com/office/drawing/2014/main" id="{04F4628A-7FCB-4B2C-887E-9DA80D05D075}"/>
               </a:ext>
             </a:extLst>
           </p:cNvPr>
@@ -5151,7 +5265,7 @@
     </p:spTree>
     <p:extLst>
       <p:ext uri="{BB962C8B-B14F-4D97-AF65-F5344CB8AC3E}">
-        <p14:creationId xmlns:p14="http://schemas.microsoft.com/office/powerpoint/2010/main" val="2074614446"/>
+        <p14:creationId xmlns:p14="http://schemas.microsoft.com/office/powerpoint/2010/main" val="36497498"/>
       </p:ext>
     </p:extLst>
   </p:cSld>
@@ -5182,7 +5296,7 @@
           <p:cNvPr id="6" name="">
             <a:extLst xmlns:a="http://schemas.openxmlformats.org/drawingml/2006/main">
               <a:ext uri="{FF2B5EF4-FFF2-40B4-BE49-F238E27FC236}">
-                <a16:creationId xmlns:a16="http://schemas.microsoft.com/office/drawing/2014/main" id="{5949D2B0-FADE-4A78-A14D-6FE16649C24A}"/>
+                <a16:creationId xmlns:a16="http://schemas.microsoft.com/office/drawing/2014/main" id="{F0232F80-084A-4408-948D-FF1C8B3BD081}"/>
               </a:ext>
             </a:extLst>
           </p:cNvPr>
@@ -5243,7 +5357,7 @@
           <p:nvPr/>
         </p:nvPicPr>
         <p:blipFill>
-          <a:blip xmlns:r="http://schemas.openxmlformats.org/officeDocument/2006/relationships" xmlns:a="http://schemas.openxmlformats.org/drawingml/2006/main" r:embed="Re5a3f39aa02f4e10"/>
+          <a:blip xmlns:r="http://schemas.openxmlformats.org/officeDocument/2006/relationships" xmlns:a="http://schemas.openxmlformats.org/drawingml/2006/main" r:embed="R5b58983700114535"/>
           <a:stretch xmlns:a="http://schemas.openxmlformats.org/drawingml/2006/main"/>
         </p:blipFill>
         <p:spPr>
@@ -5265,7 +5379,7 @@
           <p:nvPr/>
         </p:nvPicPr>
         <p:blipFill>
-          <a:blip xmlns:r="http://schemas.openxmlformats.org/officeDocument/2006/relationships" xmlns:a="http://schemas.openxmlformats.org/drawingml/2006/main" r:embed="R5e3a0ca368a8460f"/>
+          <a:blip xmlns:r="http://schemas.openxmlformats.org/officeDocument/2006/relationships" xmlns:a="http://schemas.openxmlformats.org/drawingml/2006/main" r:embed="R696364047ad944ce"/>
           <a:stretch xmlns:a="http://schemas.openxmlformats.org/drawingml/2006/main"/>
         </p:blipFill>
         <p:spPr>
@@ -5283,7 +5397,7 @@
           <p:cNvPr id="4" name="">
             <a:extLst xmlns:a="http://schemas.openxmlformats.org/drawingml/2006/main">
               <a:ext uri="{FF2B5EF4-FFF2-40B4-BE49-F238E27FC236}">
-                <a16:creationId xmlns:a16="http://schemas.microsoft.com/office/drawing/2014/main" id="{5C465B06-3BE3-478A-928C-132D2E5E06AF}"/>
+                <a16:creationId xmlns:a16="http://schemas.microsoft.com/office/drawing/2014/main" id="{F1D2A665-7B0F-4D15-9D43-BADD4A5EFA9D}"/>
               </a:ext>
             </a:extLst>
           </p:cNvPr>
@@ -5340,7 +5454,7 @@
           <p:cNvPr id="5" name="">
             <a:extLst xmlns:a="http://schemas.openxmlformats.org/drawingml/2006/main">
               <a:ext uri="{FF2B5EF4-FFF2-40B4-BE49-F238E27FC236}">
-                <a16:creationId xmlns:a16="http://schemas.microsoft.com/office/drawing/2014/main" id="{2FEFE08D-6289-48C9-84B2-A938AEF581B3}"/>
+                <a16:creationId xmlns:a16="http://schemas.microsoft.com/office/drawing/2014/main" id="{5507A6CD-D034-4067-A629-84FD76620225}"/>
               </a:ext>
             </a:extLst>
           </p:cNvPr>
@@ -5395,7 +5509,7 @@
     </p:spTree>
     <p:extLst>
       <p:ext uri="{BB962C8B-B14F-4D97-AF65-F5344CB8AC3E}">
-        <p14:creationId xmlns:p14="http://schemas.microsoft.com/office/powerpoint/2010/main" val="1109322595"/>
+        <p14:creationId xmlns:p14="http://schemas.microsoft.com/office/powerpoint/2010/main" val="1179814421"/>
       </p:ext>
     </p:extLst>
   </p:cSld>
@@ -5426,7 +5540,7 @@
           <p:cNvPr id="6" name="">
             <a:extLst xmlns:a="http://schemas.openxmlformats.org/drawingml/2006/main">
               <a:ext uri="{FF2B5EF4-FFF2-40B4-BE49-F238E27FC236}">
-                <a16:creationId xmlns:a16="http://schemas.microsoft.com/office/drawing/2014/main" id="{CD9F2AB8-F212-4107-A52A-FE4B33271A8C}"/>
+                <a16:creationId xmlns:a16="http://schemas.microsoft.com/office/drawing/2014/main" id="{40AF8FBE-5217-4AB0-8A34-93BD5E986893}"/>
               </a:ext>
             </a:extLst>
           </p:cNvPr>
@@ -5510,7 +5624,7 @@
           <p:nvPr/>
         </p:nvPicPr>
         <p:blipFill>
-          <a:blip xmlns:r="http://schemas.openxmlformats.org/officeDocument/2006/relationships" xmlns:a="http://schemas.openxmlformats.org/drawingml/2006/main" r:embed="R5452643b71c14175"/>
+          <a:blip xmlns:r="http://schemas.openxmlformats.org/officeDocument/2006/relationships" xmlns:a="http://schemas.openxmlformats.org/drawingml/2006/main" r:embed="Racd1e4f8ab384ff1"/>
           <a:stretch xmlns:a="http://schemas.openxmlformats.org/drawingml/2006/main"/>
         </p:blipFill>
         <p:spPr>
@@ -5528,7 +5642,7 @@
           <p:cNvPr id="3" name="">
             <a:extLst xmlns:a="http://schemas.openxmlformats.org/drawingml/2006/main">
               <a:ext uri="{FF2B5EF4-FFF2-40B4-BE49-F238E27FC236}">
-                <a16:creationId xmlns:a16="http://schemas.microsoft.com/office/drawing/2014/main" id="{BE933CD2-43F0-4536-BC9C-9268782AC004}"/>
+                <a16:creationId xmlns:a16="http://schemas.microsoft.com/office/drawing/2014/main" id="{08CFE3B6-1EE9-4119-9206-41F7698E52CD}"/>
               </a:ext>
             </a:extLst>
           </p:cNvPr>
@@ -5631,7 +5745,7 @@
           <p:cNvPr id="4" name="">
             <a:extLst xmlns:a="http://schemas.openxmlformats.org/drawingml/2006/main">
               <a:ext uri="{FF2B5EF4-FFF2-40B4-BE49-F238E27FC236}">
-                <a16:creationId xmlns:a16="http://schemas.microsoft.com/office/drawing/2014/main" id="{B06FF8DE-A112-46B8-94CE-BBF14FFDDEFE}"/>
+                <a16:creationId xmlns:a16="http://schemas.microsoft.com/office/drawing/2014/main" id="{BD5315BB-9212-4731-8B26-A5035904644E}"/>
               </a:ext>
             </a:extLst>
           </p:cNvPr>
@@ -5711,7 +5825,7 @@
           <p:cNvPr id="5" name="">
             <a:extLst xmlns:a="http://schemas.openxmlformats.org/drawingml/2006/main">
               <a:ext uri="{FF2B5EF4-FFF2-40B4-BE49-F238E27FC236}">
-                <a16:creationId xmlns:a16="http://schemas.microsoft.com/office/drawing/2014/main" id="{BB6C3119-595E-488A-80B2-70C982948485}"/>
+                <a16:creationId xmlns:a16="http://schemas.microsoft.com/office/drawing/2014/main" id="{F495EE4C-5D41-47EE-A8D2-B1C0752F51E8}"/>
               </a:ext>
             </a:extLst>
           </p:cNvPr>
@@ -5766,7 +5880,7 @@
     </p:spTree>
     <p:extLst>
       <p:ext uri="{BB962C8B-B14F-4D97-AF65-F5344CB8AC3E}">
-        <p14:creationId xmlns:p14="http://schemas.microsoft.com/office/powerpoint/2010/main" val="475138123"/>
+        <p14:creationId xmlns:p14="http://schemas.microsoft.com/office/powerpoint/2010/main" val="615664577"/>
       </p:ext>
     </p:extLst>
   </p:cSld>
@@ -5797,7 +5911,7 @@
           <p:cNvPr id="8" name="">
             <a:extLst xmlns:a="http://schemas.openxmlformats.org/drawingml/2006/main">
               <a:ext uri="{FF2B5EF4-FFF2-40B4-BE49-F238E27FC236}">
-                <a16:creationId xmlns:a16="http://schemas.microsoft.com/office/drawing/2014/main" id="{9AB97510-F312-40A2-A269-E0F07F5D4674}"/>
+                <a16:creationId xmlns:a16="http://schemas.microsoft.com/office/drawing/2014/main" id="{D3C92F95-26B3-4B6C-90F9-7272A98DF6C0}"/>
               </a:ext>
             </a:extLst>
           </p:cNvPr>
@@ -5881,7 +5995,7 @@
           <p:nvPr/>
         </p:nvPicPr>
         <p:blipFill>
-          <a:blip xmlns:r="http://schemas.openxmlformats.org/officeDocument/2006/relationships" xmlns:a="http://schemas.openxmlformats.org/drawingml/2006/main" r:embed="R0fb51989e9434e68"/>
+          <a:blip xmlns:r="http://schemas.openxmlformats.org/officeDocument/2006/relationships" xmlns:a="http://schemas.openxmlformats.org/drawingml/2006/main" r:embed="Rc11da4a295a3478a"/>
           <a:stretch xmlns:a="http://schemas.openxmlformats.org/drawingml/2006/main"/>
         </p:blipFill>
         <p:spPr>
@@ -5899,7 +6013,7 @@
           <p:cNvPr id="3" name="">
             <a:extLst xmlns:a="http://schemas.openxmlformats.org/drawingml/2006/main">
               <a:ext uri="{FF2B5EF4-FFF2-40B4-BE49-F238E27FC236}">
-                <a16:creationId xmlns:a16="http://schemas.microsoft.com/office/drawing/2014/main" id="{6D6D3BCC-D0C3-4B4F-BFC5-C2C455DF360D}"/>
+                <a16:creationId xmlns:a16="http://schemas.microsoft.com/office/drawing/2014/main" id="{307AD160-760C-47E8-95A3-FF7ADA6EEB12}"/>
               </a:ext>
             </a:extLst>
           </p:cNvPr>
@@ -5956,7 +6070,7 @@
           <p:cNvPr id="4" name="">
             <a:extLst xmlns:a="http://schemas.openxmlformats.org/drawingml/2006/main">
               <a:ext uri="{FF2B5EF4-FFF2-40B4-BE49-F238E27FC236}">
-                <a16:creationId xmlns:a16="http://schemas.microsoft.com/office/drawing/2014/main" id="{628B9943-D249-4B09-A4FE-7BF91B7BAFA8}"/>
+                <a16:creationId xmlns:a16="http://schemas.microsoft.com/office/drawing/2014/main" id="{161B6C87-2582-47E2-92B2-A51B9078D4B6}"/>
               </a:ext>
             </a:extLst>
           </p:cNvPr>
@@ -6013,7 +6127,7 @@
           <p:cNvPr id="5" name="">
             <a:extLst xmlns:a="http://schemas.openxmlformats.org/drawingml/2006/main">
               <a:ext uri="{FF2B5EF4-FFF2-40B4-BE49-F238E27FC236}">
-                <a16:creationId xmlns:a16="http://schemas.microsoft.com/office/drawing/2014/main" id="{EB3CCA45-0186-41C4-B8CB-4DD85AA1CFDF}"/>
+                <a16:creationId xmlns:a16="http://schemas.microsoft.com/office/drawing/2014/main" id="{627EE184-6178-4B71-A14D-A2D366667C28}"/>
               </a:ext>
             </a:extLst>
           </p:cNvPr>
@@ -6070,7 +6184,7 @@
           <p:cNvPr id="6" name="">
             <a:extLst xmlns:a="http://schemas.openxmlformats.org/drawingml/2006/main">
               <a:ext uri="{FF2B5EF4-FFF2-40B4-BE49-F238E27FC236}">
-                <a16:creationId xmlns:a16="http://schemas.microsoft.com/office/drawing/2014/main" id="{CA9399EC-F7CC-4025-A425-BBE6B806CAC8}"/>
+                <a16:creationId xmlns:a16="http://schemas.microsoft.com/office/drawing/2014/main" id="{3CFC55FF-CDE9-4B0B-BC25-CB3A2DBB15CE}"/>
               </a:ext>
             </a:extLst>
           </p:cNvPr>
@@ -6127,7 +6241,7 @@
           <p:cNvPr id="7" name="">
             <a:extLst xmlns:a="http://schemas.openxmlformats.org/drawingml/2006/main">
               <a:ext uri="{FF2B5EF4-FFF2-40B4-BE49-F238E27FC236}">
-                <a16:creationId xmlns:a16="http://schemas.microsoft.com/office/drawing/2014/main" id="{4CF83B56-0491-4A0A-9380-B5CC5FA3677E}"/>
+                <a16:creationId xmlns:a16="http://schemas.microsoft.com/office/drawing/2014/main" id="{1D7B99E6-494B-4DAC-8386-616B74BA5A4C}"/>
               </a:ext>
             </a:extLst>
           </p:cNvPr>
@@ -6182,7 +6296,7 @@
     </p:spTree>
     <p:extLst>
       <p:ext uri="{BB962C8B-B14F-4D97-AF65-F5344CB8AC3E}">
-        <p14:creationId xmlns:p14="http://schemas.microsoft.com/office/powerpoint/2010/main" val="283134877"/>
+        <p14:creationId xmlns:p14="http://schemas.microsoft.com/office/powerpoint/2010/main" val="309946081"/>
       </p:ext>
     </p:extLst>
   </p:cSld>
@@ -6213,7 +6327,7 @@
           <p:cNvPr id="3" name="">
             <a:extLst xmlns:a="http://schemas.openxmlformats.org/drawingml/2006/main">
               <a:ext uri="{FF2B5EF4-FFF2-40B4-BE49-F238E27FC236}">
-                <a16:creationId xmlns:a16="http://schemas.microsoft.com/office/drawing/2014/main" id="{02D1BC2C-3B7A-40B3-B14A-29C8080FC7A0}"/>
+                <a16:creationId xmlns:a16="http://schemas.microsoft.com/office/drawing/2014/main" id="{EC7DA380-554E-464F-99FE-9D427073D789}"/>
               </a:ext>
             </a:extLst>
           </p:cNvPr>
@@ -6297,7 +6411,7 @@
           <p:nvPr/>
         </p:nvPicPr>
         <p:blipFill>
-          <a:blip xmlns:r="http://schemas.openxmlformats.org/officeDocument/2006/relationships" xmlns:a="http://schemas.openxmlformats.org/drawingml/2006/main" r:embed="Raec0cc55833c458f"/>
+          <a:blip xmlns:r="http://schemas.openxmlformats.org/officeDocument/2006/relationships" xmlns:a="http://schemas.openxmlformats.org/drawingml/2006/main" r:embed="Rc8a097b9992b455f"/>
           <a:stretch xmlns:a="http://schemas.openxmlformats.org/drawingml/2006/main"/>
         </p:blipFill>
         <p:spPr>
@@ -6313,7 +6427,7 @@
     </p:spTree>
     <p:extLst>
       <p:ext uri="{BB962C8B-B14F-4D97-AF65-F5344CB8AC3E}">
-        <p14:creationId xmlns:p14="http://schemas.microsoft.com/office/powerpoint/2010/main" val="1836149954"/>
+        <p14:creationId xmlns:p14="http://schemas.microsoft.com/office/powerpoint/2010/main" val="1004230425"/>
       </p:ext>
     </p:extLst>
   </p:cSld>
@@ -6344,7 +6458,7 @@
           <p:cNvPr id="5" name="">
             <a:extLst xmlns:a="http://schemas.openxmlformats.org/drawingml/2006/main">
               <a:ext uri="{FF2B5EF4-FFF2-40B4-BE49-F238E27FC236}">
-                <a16:creationId xmlns:a16="http://schemas.microsoft.com/office/drawing/2014/main" id="{FC4FA073-EEC5-4E31-B163-93EE2A916921}"/>
+                <a16:creationId xmlns:a16="http://schemas.microsoft.com/office/drawing/2014/main" id="{76228CA1-B798-4BC9-A261-2B6F0F7717C3}"/>
               </a:ext>
             </a:extLst>
           </p:cNvPr>
@@ -6424,7 +6538,7 @@
           <p:cNvPr id="2" name="">
             <a:extLst xmlns:a="http://schemas.openxmlformats.org/drawingml/2006/main">
               <a:ext uri="{FF2B5EF4-FFF2-40B4-BE49-F238E27FC236}">
-                <a16:creationId xmlns:a16="http://schemas.microsoft.com/office/drawing/2014/main" id="{765A49CC-1414-4D3C-8A84-CD7DC7A21689}"/>
+                <a16:creationId xmlns:a16="http://schemas.microsoft.com/office/drawing/2014/main" id="{F683618B-3FE5-426B-86B4-1DD42FC6EC12}"/>
               </a:ext>
             </a:extLst>
           </p:cNvPr>
@@ -6527,7 +6641,7 @@
           <p:cNvPr id="3" name="">
             <a:extLst xmlns:a="http://schemas.openxmlformats.org/drawingml/2006/main">
               <a:ext uri="{FF2B5EF4-FFF2-40B4-BE49-F238E27FC236}">
-                <a16:creationId xmlns:a16="http://schemas.microsoft.com/office/drawing/2014/main" id="{BF1203CF-DC92-40A6-9048-73DB4FDB8FB6}"/>
+                <a16:creationId xmlns:a16="http://schemas.microsoft.com/office/drawing/2014/main" id="{42D14C4A-DCD1-4FE9-97C6-FB1051F8F69C}"/>
               </a:ext>
             </a:extLst>
           </p:cNvPr>
@@ -6611,7 +6725,7 @@
           <p:nvPr/>
         </p:nvPicPr>
         <p:blipFill>
-          <a:blip xmlns:r="http://schemas.openxmlformats.org/officeDocument/2006/relationships" xmlns:a="http://schemas.openxmlformats.org/drawingml/2006/main" r:embed="R55809fba390447be"/>
+          <a:blip xmlns:r="http://schemas.openxmlformats.org/officeDocument/2006/relationships" xmlns:a="http://schemas.openxmlformats.org/drawingml/2006/main" r:embed="R49faf317b0a24b14"/>
           <a:stretch xmlns:a="http://schemas.openxmlformats.org/drawingml/2006/main"/>
         </p:blipFill>
         <p:spPr>
@@ -6627,7 +6741,7 @@
     </p:spTree>
     <p:extLst>
       <p:ext uri="{BB962C8B-B14F-4D97-AF65-F5344CB8AC3E}">
-        <p14:creationId xmlns:p14="http://schemas.microsoft.com/office/powerpoint/2010/main" val="952670602"/>
+        <p14:creationId xmlns:p14="http://schemas.microsoft.com/office/powerpoint/2010/main" val="1598304749"/>
       </p:ext>
     </p:extLst>
   </p:cSld>

</xml_diff>